<commit_message>
swarm ex weekly updates
</commit_message>
<xml_diff>
--- a/SWARM-EX/Planning/Quad_Chart_TEMPLATE S25.pptx
+++ b/SWARM-EX/Planning/Quad_Chart_TEMPLATE S25.pptx
@@ -34,7 +34,7 @@
       </p:grpSpPr>
       <p:sp>
         <p:nvSpPr>
-          <p:cNvPr id="16" name="PlaceHolder 1"/>
+          <p:cNvPr id="14" name="PlaceHolder 1"/>
           <p:cNvSpPr>
             <a:spLocks noGrp="1"/>
           </p:cNvSpPr>
@@ -60,8 +60,9 @@
             <a:noAutofit/>
           </a:bodyPr>
           <a:p>
-            <a:r>
-              <a:rPr b="0" lang="en-US" sz="1400" spc="-1" strike="noStrike">
+            <a:pPr algn="ctr"/>
+            <a:r>
+              <a:rPr b="0" lang="en-US" sz="4400" spc="-1" strike="noStrike">
                 <a:solidFill>
                   <a:srgbClr val="000000"/>
                 </a:solidFill>
@@ -69,7 +70,7 @@
               </a:rPr>
               <a:t>Click to move the slide</a:t>
             </a:r>
-            <a:endParaRPr b="0" lang="en-US" sz="1400" spc="-1" strike="noStrike">
+            <a:endParaRPr b="0" lang="en-US" sz="4400" spc="-1" strike="noStrike">
               <a:solidFill>
                 <a:srgbClr val="000000"/>
               </a:solidFill>
@@ -80,7 +81,7 @@
       </p:sp>
       <p:sp>
         <p:nvSpPr>
-          <p:cNvPr id="17" name="PlaceHolder 2"/>
+          <p:cNvPr id="15" name="PlaceHolder 2"/>
           <p:cNvSpPr>
             <a:spLocks noGrp="1"/>
           </p:cNvSpPr>
@@ -129,7 +130,7 @@
       </p:sp>
       <p:sp>
         <p:nvSpPr>
-          <p:cNvPr id="18" name="PlaceHolder 3"/>
+          <p:cNvPr id="16" name="PlaceHolder 3"/>
           <p:cNvSpPr>
             <a:spLocks noGrp="1"/>
           </p:cNvSpPr>
@@ -178,7 +179,7 @@
       </p:sp>
       <p:sp>
         <p:nvSpPr>
-          <p:cNvPr id="19" name="PlaceHolder 4"/>
+          <p:cNvPr id="17" name="PlaceHolder 4"/>
           <p:cNvSpPr>
             <a:spLocks noGrp="1"/>
           </p:cNvSpPr>
@@ -238,7 +239,7 @@
       </p:sp>
       <p:sp>
         <p:nvSpPr>
-          <p:cNvPr id="20" name="PlaceHolder 5"/>
+          <p:cNvPr id="18" name="PlaceHolder 5"/>
           <p:cNvSpPr>
             <a:spLocks noGrp="1"/>
           </p:cNvSpPr>
@@ -298,7 +299,7 @@
       </p:sp>
       <p:sp>
         <p:nvSpPr>
-          <p:cNvPr id="21" name="PlaceHolder 6"/>
+          <p:cNvPr id="19" name="PlaceHolder 6"/>
           <p:cNvSpPr>
             <a:spLocks noGrp="1"/>
           </p:cNvSpPr>
@@ -338,7 +339,7 @@
             <a:pPr indent="0" algn="r">
               <a:buNone/>
             </a:pPr>
-            <a:fld id="{ECF54B9E-F01E-4D09-B62B-049A683D0F0E}" type="slidenum">
+            <a:fld id="{AF5A0476-118F-462A-83BE-4E8505F036AC}" type="slidenum">
               <a:rPr b="0" lang="en-US" sz="1400" spc="-1" strike="noStrike">
                 <a:solidFill>
                   <a:srgbClr val="000000"/>
@@ -381,7 +382,7 @@
       </p:grpSpPr>
       <p:sp>
         <p:nvSpPr>
-          <p:cNvPr id="29" name="PlaceHolder 1"/>
+          <p:cNvPr id="27" name="PlaceHolder 1"/>
           <p:cNvSpPr>
             <a:spLocks noGrp="1"/>
           </p:cNvSpPr>
@@ -392,7 +393,7 @@
         <p:spPr>
           <a:xfrm>
             <a:off x="380880" y="685800"/>
-            <a:ext cx="6095520" cy="3428640"/>
+            <a:ext cx="6095160" cy="3428280"/>
           </a:xfrm>
           <a:prstGeom prst="rect">
             <a:avLst/>
@@ -404,7 +405,7 @@
       </p:sp>
       <p:sp>
         <p:nvSpPr>
-          <p:cNvPr id="30" name="PlaceHolder 2"/>
+          <p:cNvPr id="28" name="PlaceHolder 2"/>
           <p:cNvSpPr>
             <a:spLocks noGrp="1"/>
           </p:cNvSpPr>
@@ -415,7 +416,7 @@
         <p:spPr>
           <a:xfrm>
             <a:off x="685800" y="4343400"/>
-            <a:ext cx="5486040" cy="4114440"/>
+            <a:ext cx="5485680" cy="4114080"/>
           </a:xfrm>
           <a:prstGeom prst="rect">
             <a:avLst/>
@@ -430,7 +431,7 @@
             <a:noAutofit/>
           </a:bodyPr>
           <a:p>
-            <a:pPr indent="0">
+            <a:pPr marL="216000" indent="0">
               <a:lnSpc>
                 <a:spcPct val="100000"/>
               </a:lnSpc>
@@ -743,7 +744,7 @@
             </a:endParaRPr>
           </a:p>
           <a:p>
-            <a:pPr indent="0">
+            <a:pPr marL="457200" indent="0">
               <a:lnSpc>
                 <a:spcPct val="100000"/>
               </a:lnSpc>
@@ -937,7 +938,7 @@
         <p:spPr>
           <a:xfrm>
             <a:off x="4588560" y="2575800"/>
-            <a:ext cx="4571640" cy="279360"/>
+            <a:ext cx="4571280" cy="279000"/>
           </a:xfrm>
           <a:prstGeom prst="rect">
             <a:avLst/>
@@ -1007,7 +1008,7 @@
         <p:spPr>
           <a:xfrm>
             <a:off x="0" y="2566080"/>
-            <a:ext cx="4571640" cy="279360"/>
+            <a:ext cx="4571280" cy="279000"/>
           </a:xfrm>
           <a:prstGeom prst="rect">
             <a:avLst/>
@@ -1087,7 +1088,7 @@
         <p:spPr>
           <a:xfrm>
             <a:off x="0" y="2565720"/>
-            <a:ext cx="9144360" cy="360"/>
+            <a:ext cx="9144720" cy="720"/>
           </a:xfrm>
           <a:prstGeom prst="straightConnector1">
             <a:avLst/>
@@ -1109,7 +1110,7 @@
         <p:spPr>
           <a:xfrm>
             <a:off x="4572000" y="561960"/>
-            <a:ext cx="4571640" cy="279360"/>
+            <a:ext cx="4571280" cy="279000"/>
           </a:xfrm>
           <a:prstGeom prst="rect">
             <a:avLst/>
@@ -1189,7 +1190,7 @@
         <p:spPr>
           <a:xfrm>
             <a:off x="0" y="561960"/>
-            <a:ext cx="4571640" cy="279360"/>
+            <a:ext cx="4571280" cy="279000"/>
           </a:xfrm>
           <a:prstGeom prst="rect">
             <a:avLst/>
@@ -1272,7 +1273,7 @@
         <p:spPr>
           <a:xfrm flipV="1">
             <a:off x="4572000" y="561600"/>
-            <a:ext cx="9720" cy="4065480"/>
+            <a:ext cx="10080" cy="4065840"/>
           </a:xfrm>
           <a:prstGeom prst="straightConnector1">
             <a:avLst/>
@@ -1294,7 +1295,7 @@
         <p:spPr>
           <a:xfrm>
             <a:off x="8027280" y="4749120"/>
-            <a:ext cx="1204200" cy="336960"/>
+            <a:ext cx="1203840" cy="336600"/>
           </a:xfrm>
           <a:prstGeom prst="rect">
             <a:avLst/>
@@ -1311,7 +1312,7 @@
           <a:fontRef idx="minor"/>
         </p:style>
         <p:txBody>
-          <a:bodyPr tIns="91440" bIns="91440" anchor="t">
+          <a:bodyPr lIns="90000" rIns="90000" tIns="91440" bIns="91440" anchor="t">
             <a:noAutofit/>
           </a:bodyPr>
           <a:p>
@@ -1351,7 +1352,7 @@
         <p:spPr>
           <a:xfrm>
             <a:off x="3893400" y="4749120"/>
-            <a:ext cx="2532600" cy="336960"/>
+            <a:ext cx="2532240" cy="336600"/>
           </a:xfrm>
           <a:prstGeom prst="rect">
             <a:avLst/>
@@ -1368,7 +1369,7 @@
           <a:fontRef idx="minor"/>
         </p:style>
         <p:txBody>
-          <a:bodyPr tIns="91440" bIns="91440" anchor="t">
+          <a:bodyPr lIns="90000" rIns="90000" tIns="91440" bIns="91440" anchor="t">
             <a:noAutofit/>
           </a:bodyPr>
           <a:p>
@@ -1391,906 +1392,6 @@
               <a:t>Graduate Projects</a:t>
             </a:r>
             <a:endParaRPr b="0" lang="en-US" sz="1200" spc="-1" strike="noStrike">
-              <a:solidFill>
-                <a:srgbClr val="000000"/>
-              </a:solidFill>
-              <a:latin typeface="Arial"/>
-            </a:endParaRPr>
-          </a:p>
-        </p:txBody>
-      </p:sp>
-      <p:sp>
-        <p:nvSpPr>
-          <p:cNvPr id="8" name="PlaceHolder 1"/>
-          <p:cNvSpPr>
-            <a:spLocks noGrp="1"/>
-          </p:cNvSpPr>
-          <p:nvPr>
-            <p:ph type="body"/>
-          </p:nvPr>
-        </p:nvSpPr>
-        <p:spPr>
-          <a:xfrm>
-            <a:off x="-11880" y="864000"/>
-            <a:ext cx="4571640" cy="1701720"/>
-          </a:xfrm>
-          <a:prstGeom prst="rect">
-            <a:avLst/>
-          </a:prstGeom>
-          <a:noFill/>
-          <a:ln w="0">
-            <a:noFill/>
-          </a:ln>
-        </p:spPr>
-        <p:txBody>
-          <a:bodyPr lIns="91440" rIns="91440" tIns="91440" bIns="91440" anchor="t">
-            <a:noAutofit/>
-          </a:bodyPr>
-          <a:p>
-            <a:pPr marL="432000" indent="-324000">
-              <a:spcBef>
-                <a:spcPts val="1417"/>
-              </a:spcBef>
-              <a:buClr>
-                <a:srgbClr val="000000"/>
-              </a:buClr>
-              <a:buSzPct val="45000"/>
-              <a:buFont typeface="Wingdings" charset="2"/>
-              <a:buChar char=""/>
-            </a:pPr>
-            <a:r>
-              <a:rPr b="0" lang="en-US" sz="1400" spc="-1" strike="noStrike">
-                <a:solidFill>
-                  <a:srgbClr val="000000"/>
-                </a:solidFill>
-                <a:latin typeface="Arial"/>
-              </a:rPr>
-              <a:t>Click to edit the outline text format</a:t>
-            </a:r>
-            <a:endParaRPr b="0" lang="en-US" sz="1400" spc="-1" strike="noStrike">
-              <a:solidFill>
-                <a:srgbClr val="000000"/>
-              </a:solidFill>
-              <a:latin typeface="Arial"/>
-            </a:endParaRPr>
-          </a:p>
-          <a:p>
-            <a:pPr lvl="1" marL="864000" indent="-324000">
-              <a:spcBef>
-                <a:spcPts val="1134"/>
-              </a:spcBef>
-              <a:buClr>
-                <a:srgbClr val="000000"/>
-              </a:buClr>
-              <a:buSzPct val="75000"/>
-              <a:buFont typeface="Symbol" charset="2"/>
-              <a:buChar char=""/>
-            </a:pPr>
-            <a:r>
-              <a:rPr b="0" lang="en-US" sz="1400" spc="-1" strike="noStrike">
-                <a:solidFill>
-                  <a:srgbClr val="000000"/>
-                </a:solidFill>
-                <a:latin typeface="Arial"/>
-              </a:rPr>
-              <a:t>Second Outline Level</a:t>
-            </a:r>
-            <a:endParaRPr b="0" lang="en-US" sz="1400" spc="-1" strike="noStrike">
-              <a:solidFill>
-                <a:srgbClr val="000000"/>
-              </a:solidFill>
-              <a:latin typeface="Arial"/>
-            </a:endParaRPr>
-          </a:p>
-          <a:p>
-            <a:pPr lvl="2" marL="1296000" indent="-288000">
-              <a:spcBef>
-                <a:spcPts val="850"/>
-              </a:spcBef>
-              <a:buClr>
-                <a:srgbClr val="000000"/>
-              </a:buClr>
-              <a:buSzPct val="45000"/>
-              <a:buFont typeface="Wingdings" charset="2"/>
-              <a:buChar char=""/>
-            </a:pPr>
-            <a:r>
-              <a:rPr b="0" lang="en-US" sz="1400" spc="-1" strike="noStrike">
-                <a:solidFill>
-                  <a:srgbClr val="000000"/>
-                </a:solidFill>
-                <a:latin typeface="Arial"/>
-              </a:rPr>
-              <a:t>Third Outline Level</a:t>
-            </a:r>
-            <a:endParaRPr b="0" lang="en-US" sz="1400" spc="-1" strike="noStrike">
-              <a:solidFill>
-                <a:srgbClr val="000000"/>
-              </a:solidFill>
-              <a:latin typeface="Arial"/>
-            </a:endParaRPr>
-          </a:p>
-          <a:p>
-            <a:pPr lvl="3" marL="1728000" indent="-216000">
-              <a:spcBef>
-                <a:spcPts val="567"/>
-              </a:spcBef>
-              <a:buClr>
-                <a:srgbClr val="000000"/>
-              </a:buClr>
-              <a:buSzPct val="75000"/>
-              <a:buFont typeface="Symbol" charset="2"/>
-              <a:buChar char=""/>
-            </a:pPr>
-            <a:r>
-              <a:rPr b="0" lang="en-US" sz="1400" spc="-1" strike="noStrike">
-                <a:solidFill>
-                  <a:srgbClr val="000000"/>
-                </a:solidFill>
-                <a:latin typeface="Arial"/>
-              </a:rPr>
-              <a:t>Fourth Outline Level</a:t>
-            </a:r>
-            <a:endParaRPr b="0" lang="en-US" sz="1400" spc="-1" strike="noStrike">
-              <a:solidFill>
-                <a:srgbClr val="000000"/>
-              </a:solidFill>
-              <a:latin typeface="Arial"/>
-            </a:endParaRPr>
-          </a:p>
-          <a:p>
-            <a:pPr lvl="4" marL="2160000" indent="-216000">
-              <a:spcBef>
-                <a:spcPts val="283"/>
-              </a:spcBef>
-              <a:buClr>
-                <a:srgbClr val="000000"/>
-              </a:buClr>
-              <a:buSzPct val="45000"/>
-              <a:buFont typeface="Wingdings" charset="2"/>
-              <a:buChar char=""/>
-            </a:pPr>
-            <a:r>
-              <a:rPr b="0" lang="en-US" sz="1400" spc="-1" strike="noStrike">
-                <a:solidFill>
-                  <a:srgbClr val="000000"/>
-                </a:solidFill>
-                <a:latin typeface="Arial"/>
-              </a:rPr>
-              <a:t>Fifth Outline Level</a:t>
-            </a:r>
-            <a:endParaRPr b="0" lang="en-US" sz="1400" spc="-1" strike="noStrike">
-              <a:solidFill>
-                <a:srgbClr val="000000"/>
-              </a:solidFill>
-              <a:latin typeface="Arial"/>
-            </a:endParaRPr>
-          </a:p>
-          <a:p>
-            <a:pPr lvl="5" marL="2592000" indent="-216000">
-              <a:spcBef>
-                <a:spcPts val="283"/>
-              </a:spcBef>
-              <a:buClr>
-                <a:srgbClr val="000000"/>
-              </a:buClr>
-              <a:buSzPct val="45000"/>
-              <a:buFont typeface="Wingdings" charset="2"/>
-              <a:buChar char=""/>
-            </a:pPr>
-            <a:r>
-              <a:rPr b="0" lang="en-US" sz="1400" spc="-1" strike="noStrike">
-                <a:solidFill>
-                  <a:srgbClr val="000000"/>
-                </a:solidFill>
-                <a:latin typeface="Arial"/>
-              </a:rPr>
-              <a:t>Sixth Outline Level</a:t>
-            </a:r>
-            <a:endParaRPr b="0" lang="en-US" sz="1400" spc="-1" strike="noStrike">
-              <a:solidFill>
-                <a:srgbClr val="000000"/>
-              </a:solidFill>
-              <a:latin typeface="Arial"/>
-            </a:endParaRPr>
-          </a:p>
-          <a:p>
-            <a:pPr lvl="6" marL="3024000" indent="-216000">
-              <a:spcBef>
-                <a:spcPts val="283"/>
-              </a:spcBef>
-              <a:buClr>
-                <a:srgbClr val="000000"/>
-              </a:buClr>
-              <a:buSzPct val="45000"/>
-              <a:buFont typeface="Wingdings" charset="2"/>
-              <a:buChar char=""/>
-            </a:pPr>
-            <a:r>
-              <a:rPr b="0" lang="en-US" sz="1400" spc="-1" strike="noStrike">
-                <a:solidFill>
-                  <a:srgbClr val="000000"/>
-                </a:solidFill>
-                <a:latin typeface="Arial"/>
-              </a:rPr>
-              <a:t>Seventh Outline Level</a:t>
-            </a:r>
-            <a:endParaRPr b="0" lang="en-US" sz="1400" spc="-1" strike="noStrike">
-              <a:solidFill>
-                <a:srgbClr val="000000"/>
-              </a:solidFill>
-              <a:latin typeface="Arial"/>
-            </a:endParaRPr>
-          </a:p>
-        </p:txBody>
-      </p:sp>
-      <p:sp>
-        <p:nvSpPr>
-          <p:cNvPr id="9" name="PlaceHolder 2"/>
-          <p:cNvSpPr>
-            <a:spLocks noGrp="1"/>
-          </p:cNvSpPr>
-          <p:nvPr>
-            <p:ph type="body"/>
-          </p:nvPr>
-        </p:nvSpPr>
-        <p:spPr>
-          <a:xfrm>
-            <a:off x="4572000" y="864000"/>
-            <a:ext cx="4571640" cy="1701720"/>
-          </a:xfrm>
-          <a:prstGeom prst="rect">
-            <a:avLst/>
-          </a:prstGeom>
-          <a:noFill/>
-          <a:ln w="0">
-            <a:noFill/>
-          </a:ln>
-        </p:spPr>
-        <p:txBody>
-          <a:bodyPr lIns="91440" rIns="91440" tIns="91440" bIns="91440" anchor="t">
-            <a:noAutofit/>
-          </a:bodyPr>
-          <a:p>
-            <a:pPr marL="432000" indent="-324000">
-              <a:spcBef>
-                <a:spcPts val="1417"/>
-              </a:spcBef>
-              <a:buClr>
-                <a:srgbClr val="000000"/>
-              </a:buClr>
-              <a:buSzPct val="45000"/>
-              <a:buFont typeface="Wingdings" charset="2"/>
-              <a:buChar char=""/>
-            </a:pPr>
-            <a:r>
-              <a:rPr b="0" lang="en-US" sz="1400" spc="-1" strike="noStrike">
-                <a:solidFill>
-                  <a:srgbClr val="000000"/>
-                </a:solidFill>
-                <a:latin typeface="Arial"/>
-              </a:rPr>
-              <a:t>Click to edit the outline text format</a:t>
-            </a:r>
-            <a:endParaRPr b="0" lang="en-US" sz="1400" spc="-1" strike="noStrike">
-              <a:solidFill>
-                <a:srgbClr val="000000"/>
-              </a:solidFill>
-              <a:latin typeface="Arial"/>
-            </a:endParaRPr>
-          </a:p>
-          <a:p>
-            <a:pPr lvl="1" marL="864000" indent="-324000">
-              <a:spcBef>
-                <a:spcPts val="1134"/>
-              </a:spcBef>
-              <a:buClr>
-                <a:srgbClr val="000000"/>
-              </a:buClr>
-              <a:buSzPct val="75000"/>
-              <a:buFont typeface="Symbol" charset="2"/>
-              <a:buChar char=""/>
-            </a:pPr>
-            <a:r>
-              <a:rPr b="0" lang="en-US" sz="1400" spc="-1" strike="noStrike">
-                <a:solidFill>
-                  <a:srgbClr val="000000"/>
-                </a:solidFill>
-                <a:latin typeface="Arial"/>
-              </a:rPr>
-              <a:t>Second Outline Level</a:t>
-            </a:r>
-            <a:endParaRPr b="0" lang="en-US" sz="1400" spc="-1" strike="noStrike">
-              <a:solidFill>
-                <a:srgbClr val="000000"/>
-              </a:solidFill>
-              <a:latin typeface="Arial"/>
-            </a:endParaRPr>
-          </a:p>
-          <a:p>
-            <a:pPr lvl="2" marL="1296000" indent="-288000">
-              <a:spcBef>
-                <a:spcPts val="850"/>
-              </a:spcBef>
-              <a:buClr>
-                <a:srgbClr val="000000"/>
-              </a:buClr>
-              <a:buSzPct val="45000"/>
-              <a:buFont typeface="Wingdings" charset="2"/>
-              <a:buChar char=""/>
-            </a:pPr>
-            <a:r>
-              <a:rPr b="0" lang="en-US" sz="1400" spc="-1" strike="noStrike">
-                <a:solidFill>
-                  <a:srgbClr val="000000"/>
-                </a:solidFill>
-                <a:latin typeface="Arial"/>
-              </a:rPr>
-              <a:t>Third Outline Level</a:t>
-            </a:r>
-            <a:endParaRPr b="0" lang="en-US" sz="1400" spc="-1" strike="noStrike">
-              <a:solidFill>
-                <a:srgbClr val="000000"/>
-              </a:solidFill>
-              <a:latin typeface="Arial"/>
-            </a:endParaRPr>
-          </a:p>
-          <a:p>
-            <a:pPr lvl="3" marL="1728000" indent="-216000">
-              <a:spcBef>
-                <a:spcPts val="567"/>
-              </a:spcBef>
-              <a:buClr>
-                <a:srgbClr val="000000"/>
-              </a:buClr>
-              <a:buSzPct val="75000"/>
-              <a:buFont typeface="Symbol" charset="2"/>
-              <a:buChar char=""/>
-            </a:pPr>
-            <a:r>
-              <a:rPr b="0" lang="en-US" sz="1400" spc="-1" strike="noStrike">
-                <a:solidFill>
-                  <a:srgbClr val="000000"/>
-                </a:solidFill>
-                <a:latin typeface="Arial"/>
-              </a:rPr>
-              <a:t>Fourth Outline Level</a:t>
-            </a:r>
-            <a:endParaRPr b="0" lang="en-US" sz="1400" spc="-1" strike="noStrike">
-              <a:solidFill>
-                <a:srgbClr val="000000"/>
-              </a:solidFill>
-              <a:latin typeface="Arial"/>
-            </a:endParaRPr>
-          </a:p>
-          <a:p>
-            <a:pPr lvl="4" marL="2160000" indent="-216000">
-              <a:spcBef>
-                <a:spcPts val="283"/>
-              </a:spcBef>
-              <a:buClr>
-                <a:srgbClr val="000000"/>
-              </a:buClr>
-              <a:buSzPct val="45000"/>
-              <a:buFont typeface="Wingdings" charset="2"/>
-              <a:buChar char=""/>
-            </a:pPr>
-            <a:r>
-              <a:rPr b="0" lang="en-US" sz="1400" spc="-1" strike="noStrike">
-                <a:solidFill>
-                  <a:srgbClr val="000000"/>
-                </a:solidFill>
-                <a:latin typeface="Arial"/>
-              </a:rPr>
-              <a:t>Fifth Outline Level</a:t>
-            </a:r>
-            <a:endParaRPr b="0" lang="en-US" sz="1400" spc="-1" strike="noStrike">
-              <a:solidFill>
-                <a:srgbClr val="000000"/>
-              </a:solidFill>
-              <a:latin typeface="Arial"/>
-            </a:endParaRPr>
-          </a:p>
-          <a:p>
-            <a:pPr lvl="5" marL="2592000" indent="-216000">
-              <a:spcBef>
-                <a:spcPts val="283"/>
-              </a:spcBef>
-              <a:buClr>
-                <a:srgbClr val="000000"/>
-              </a:buClr>
-              <a:buSzPct val="45000"/>
-              <a:buFont typeface="Wingdings" charset="2"/>
-              <a:buChar char=""/>
-            </a:pPr>
-            <a:r>
-              <a:rPr b="0" lang="en-US" sz="1400" spc="-1" strike="noStrike">
-                <a:solidFill>
-                  <a:srgbClr val="000000"/>
-                </a:solidFill>
-                <a:latin typeface="Arial"/>
-              </a:rPr>
-              <a:t>Sixth Outline Level</a:t>
-            </a:r>
-            <a:endParaRPr b="0" lang="en-US" sz="1400" spc="-1" strike="noStrike">
-              <a:solidFill>
-                <a:srgbClr val="000000"/>
-              </a:solidFill>
-              <a:latin typeface="Arial"/>
-            </a:endParaRPr>
-          </a:p>
-          <a:p>
-            <a:pPr lvl="6" marL="3024000" indent="-216000">
-              <a:spcBef>
-                <a:spcPts val="283"/>
-              </a:spcBef>
-              <a:buClr>
-                <a:srgbClr val="000000"/>
-              </a:buClr>
-              <a:buSzPct val="45000"/>
-              <a:buFont typeface="Wingdings" charset="2"/>
-              <a:buChar char=""/>
-            </a:pPr>
-            <a:r>
-              <a:rPr b="0" lang="en-US" sz="1400" spc="-1" strike="noStrike">
-                <a:solidFill>
-                  <a:srgbClr val="000000"/>
-                </a:solidFill>
-                <a:latin typeface="Arial"/>
-              </a:rPr>
-              <a:t>Seventh Outline Level</a:t>
-            </a:r>
-            <a:endParaRPr b="0" lang="en-US" sz="1400" spc="-1" strike="noStrike">
-              <a:solidFill>
-                <a:srgbClr val="000000"/>
-              </a:solidFill>
-              <a:latin typeface="Arial"/>
-            </a:endParaRPr>
-          </a:p>
-        </p:txBody>
-      </p:sp>
-      <p:sp>
-        <p:nvSpPr>
-          <p:cNvPr id="10" name="PlaceHolder 3"/>
-          <p:cNvSpPr>
-            <a:spLocks noGrp="1"/>
-          </p:cNvSpPr>
-          <p:nvPr>
-            <p:ph type="body"/>
-          </p:nvPr>
-        </p:nvSpPr>
-        <p:spPr>
-          <a:xfrm>
-            <a:off x="4572000" y="2845800"/>
-            <a:ext cx="4571640" cy="1701720"/>
-          </a:xfrm>
-          <a:prstGeom prst="rect">
-            <a:avLst/>
-          </a:prstGeom>
-          <a:noFill/>
-          <a:ln w="0">
-            <a:noFill/>
-          </a:ln>
-        </p:spPr>
-        <p:txBody>
-          <a:bodyPr lIns="91440" rIns="91440" tIns="91440" bIns="91440" anchor="t">
-            <a:noAutofit/>
-          </a:bodyPr>
-          <a:p>
-            <a:pPr marL="432000" indent="-324000">
-              <a:spcBef>
-                <a:spcPts val="1417"/>
-              </a:spcBef>
-              <a:buClr>
-                <a:srgbClr val="000000"/>
-              </a:buClr>
-              <a:buSzPct val="45000"/>
-              <a:buFont typeface="Wingdings" charset="2"/>
-              <a:buChar char=""/>
-            </a:pPr>
-            <a:r>
-              <a:rPr b="0" lang="en-US" sz="1400" spc="-1" strike="noStrike">
-                <a:solidFill>
-                  <a:srgbClr val="000000"/>
-                </a:solidFill>
-                <a:latin typeface="Arial"/>
-              </a:rPr>
-              <a:t>Click to edit the outline text format</a:t>
-            </a:r>
-            <a:endParaRPr b="0" lang="en-US" sz="1400" spc="-1" strike="noStrike">
-              <a:solidFill>
-                <a:srgbClr val="000000"/>
-              </a:solidFill>
-              <a:latin typeface="Arial"/>
-            </a:endParaRPr>
-          </a:p>
-          <a:p>
-            <a:pPr lvl="1" marL="864000" indent="-324000">
-              <a:spcBef>
-                <a:spcPts val="1134"/>
-              </a:spcBef>
-              <a:buClr>
-                <a:srgbClr val="000000"/>
-              </a:buClr>
-              <a:buSzPct val="75000"/>
-              <a:buFont typeface="Symbol" charset="2"/>
-              <a:buChar char=""/>
-            </a:pPr>
-            <a:r>
-              <a:rPr b="0" lang="en-US" sz="1400" spc="-1" strike="noStrike">
-                <a:solidFill>
-                  <a:srgbClr val="000000"/>
-                </a:solidFill>
-                <a:latin typeface="Arial"/>
-              </a:rPr>
-              <a:t>Second Outline Level</a:t>
-            </a:r>
-            <a:endParaRPr b="0" lang="en-US" sz="1400" spc="-1" strike="noStrike">
-              <a:solidFill>
-                <a:srgbClr val="000000"/>
-              </a:solidFill>
-              <a:latin typeface="Arial"/>
-            </a:endParaRPr>
-          </a:p>
-          <a:p>
-            <a:pPr lvl="2" marL="1296000" indent="-288000">
-              <a:spcBef>
-                <a:spcPts val="850"/>
-              </a:spcBef>
-              <a:buClr>
-                <a:srgbClr val="000000"/>
-              </a:buClr>
-              <a:buSzPct val="45000"/>
-              <a:buFont typeface="Wingdings" charset="2"/>
-              <a:buChar char=""/>
-            </a:pPr>
-            <a:r>
-              <a:rPr b="0" lang="en-US" sz="1400" spc="-1" strike="noStrike">
-                <a:solidFill>
-                  <a:srgbClr val="000000"/>
-                </a:solidFill>
-                <a:latin typeface="Arial"/>
-              </a:rPr>
-              <a:t>Third Outline Level</a:t>
-            </a:r>
-            <a:endParaRPr b="0" lang="en-US" sz="1400" spc="-1" strike="noStrike">
-              <a:solidFill>
-                <a:srgbClr val="000000"/>
-              </a:solidFill>
-              <a:latin typeface="Arial"/>
-            </a:endParaRPr>
-          </a:p>
-          <a:p>
-            <a:pPr lvl="3" marL="1728000" indent="-216000">
-              <a:spcBef>
-                <a:spcPts val="567"/>
-              </a:spcBef>
-              <a:buClr>
-                <a:srgbClr val="000000"/>
-              </a:buClr>
-              <a:buSzPct val="75000"/>
-              <a:buFont typeface="Symbol" charset="2"/>
-              <a:buChar char=""/>
-            </a:pPr>
-            <a:r>
-              <a:rPr b="0" lang="en-US" sz="1400" spc="-1" strike="noStrike">
-                <a:solidFill>
-                  <a:srgbClr val="000000"/>
-                </a:solidFill>
-                <a:latin typeface="Arial"/>
-              </a:rPr>
-              <a:t>Fourth Outline Level</a:t>
-            </a:r>
-            <a:endParaRPr b="0" lang="en-US" sz="1400" spc="-1" strike="noStrike">
-              <a:solidFill>
-                <a:srgbClr val="000000"/>
-              </a:solidFill>
-              <a:latin typeface="Arial"/>
-            </a:endParaRPr>
-          </a:p>
-          <a:p>
-            <a:pPr lvl="4" marL="2160000" indent="-216000">
-              <a:spcBef>
-                <a:spcPts val="283"/>
-              </a:spcBef>
-              <a:buClr>
-                <a:srgbClr val="000000"/>
-              </a:buClr>
-              <a:buSzPct val="45000"/>
-              <a:buFont typeface="Wingdings" charset="2"/>
-              <a:buChar char=""/>
-            </a:pPr>
-            <a:r>
-              <a:rPr b="0" lang="en-US" sz="1400" spc="-1" strike="noStrike">
-                <a:solidFill>
-                  <a:srgbClr val="000000"/>
-                </a:solidFill>
-                <a:latin typeface="Arial"/>
-              </a:rPr>
-              <a:t>Fifth Outline Level</a:t>
-            </a:r>
-            <a:endParaRPr b="0" lang="en-US" sz="1400" spc="-1" strike="noStrike">
-              <a:solidFill>
-                <a:srgbClr val="000000"/>
-              </a:solidFill>
-              <a:latin typeface="Arial"/>
-            </a:endParaRPr>
-          </a:p>
-          <a:p>
-            <a:pPr lvl="5" marL="2592000" indent="-216000">
-              <a:spcBef>
-                <a:spcPts val="283"/>
-              </a:spcBef>
-              <a:buClr>
-                <a:srgbClr val="000000"/>
-              </a:buClr>
-              <a:buSzPct val="45000"/>
-              <a:buFont typeface="Wingdings" charset="2"/>
-              <a:buChar char=""/>
-            </a:pPr>
-            <a:r>
-              <a:rPr b="0" lang="en-US" sz="1400" spc="-1" strike="noStrike">
-                <a:solidFill>
-                  <a:srgbClr val="000000"/>
-                </a:solidFill>
-                <a:latin typeface="Arial"/>
-              </a:rPr>
-              <a:t>Sixth Outline Level</a:t>
-            </a:r>
-            <a:endParaRPr b="0" lang="en-US" sz="1400" spc="-1" strike="noStrike">
-              <a:solidFill>
-                <a:srgbClr val="000000"/>
-              </a:solidFill>
-              <a:latin typeface="Arial"/>
-            </a:endParaRPr>
-          </a:p>
-          <a:p>
-            <a:pPr lvl="6" marL="3024000" indent="-216000">
-              <a:spcBef>
-                <a:spcPts val="283"/>
-              </a:spcBef>
-              <a:buClr>
-                <a:srgbClr val="000000"/>
-              </a:buClr>
-              <a:buSzPct val="45000"/>
-              <a:buFont typeface="Wingdings" charset="2"/>
-              <a:buChar char=""/>
-            </a:pPr>
-            <a:r>
-              <a:rPr b="0" lang="en-US" sz="1400" spc="-1" strike="noStrike">
-                <a:solidFill>
-                  <a:srgbClr val="000000"/>
-                </a:solidFill>
-                <a:latin typeface="Arial"/>
-              </a:rPr>
-              <a:t>Seventh Outline Level</a:t>
-            </a:r>
-            <a:endParaRPr b="0" lang="en-US" sz="1400" spc="-1" strike="noStrike">
-              <a:solidFill>
-                <a:srgbClr val="000000"/>
-              </a:solidFill>
-              <a:latin typeface="Arial"/>
-            </a:endParaRPr>
-          </a:p>
-        </p:txBody>
-      </p:sp>
-      <p:sp>
-        <p:nvSpPr>
-          <p:cNvPr id="11" name="PlaceHolder 4"/>
-          <p:cNvSpPr>
-            <a:spLocks noGrp="1"/>
-          </p:cNvSpPr>
-          <p:nvPr>
-            <p:ph type="body"/>
-          </p:nvPr>
-        </p:nvSpPr>
-        <p:spPr>
-          <a:xfrm>
-            <a:off x="-11880" y="2845800"/>
-            <a:ext cx="4571640" cy="1701720"/>
-          </a:xfrm>
-          <a:prstGeom prst="rect">
-            <a:avLst/>
-          </a:prstGeom>
-          <a:noFill/>
-          <a:ln w="0">
-            <a:noFill/>
-          </a:ln>
-        </p:spPr>
-        <p:txBody>
-          <a:bodyPr lIns="91440" rIns="91440" tIns="91440" bIns="91440" anchor="t">
-            <a:noAutofit/>
-          </a:bodyPr>
-          <a:p>
-            <a:pPr marL="432000" indent="-324000">
-              <a:spcBef>
-                <a:spcPts val="1417"/>
-              </a:spcBef>
-              <a:buClr>
-                <a:srgbClr val="000000"/>
-              </a:buClr>
-              <a:buSzPct val="45000"/>
-              <a:buFont typeface="Wingdings" charset="2"/>
-              <a:buChar char=""/>
-            </a:pPr>
-            <a:r>
-              <a:rPr b="0" lang="en-US" sz="1400" spc="-1" strike="noStrike">
-                <a:solidFill>
-                  <a:srgbClr val="000000"/>
-                </a:solidFill>
-                <a:latin typeface="Arial"/>
-              </a:rPr>
-              <a:t>Click to edit the outline text format</a:t>
-            </a:r>
-            <a:endParaRPr b="0" lang="en-US" sz="1400" spc="-1" strike="noStrike">
-              <a:solidFill>
-                <a:srgbClr val="000000"/>
-              </a:solidFill>
-              <a:latin typeface="Arial"/>
-            </a:endParaRPr>
-          </a:p>
-          <a:p>
-            <a:pPr lvl="1" marL="864000" indent="-324000">
-              <a:spcBef>
-                <a:spcPts val="1134"/>
-              </a:spcBef>
-              <a:buClr>
-                <a:srgbClr val="000000"/>
-              </a:buClr>
-              <a:buSzPct val="75000"/>
-              <a:buFont typeface="Symbol" charset="2"/>
-              <a:buChar char=""/>
-            </a:pPr>
-            <a:r>
-              <a:rPr b="0" lang="en-US" sz="1400" spc="-1" strike="noStrike">
-                <a:solidFill>
-                  <a:srgbClr val="000000"/>
-                </a:solidFill>
-                <a:latin typeface="Arial"/>
-              </a:rPr>
-              <a:t>Second Outline Level</a:t>
-            </a:r>
-            <a:endParaRPr b="0" lang="en-US" sz="1400" spc="-1" strike="noStrike">
-              <a:solidFill>
-                <a:srgbClr val="000000"/>
-              </a:solidFill>
-              <a:latin typeface="Arial"/>
-            </a:endParaRPr>
-          </a:p>
-          <a:p>
-            <a:pPr lvl="2" marL="1296000" indent="-288000">
-              <a:spcBef>
-                <a:spcPts val="850"/>
-              </a:spcBef>
-              <a:buClr>
-                <a:srgbClr val="000000"/>
-              </a:buClr>
-              <a:buSzPct val="45000"/>
-              <a:buFont typeface="Wingdings" charset="2"/>
-              <a:buChar char=""/>
-            </a:pPr>
-            <a:r>
-              <a:rPr b="0" lang="en-US" sz="1400" spc="-1" strike="noStrike">
-                <a:solidFill>
-                  <a:srgbClr val="000000"/>
-                </a:solidFill>
-                <a:latin typeface="Arial"/>
-              </a:rPr>
-              <a:t>Third Outline Level</a:t>
-            </a:r>
-            <a:endParaRPr b="0" lang="en-US" sz="1400" spc="-1" strike="noStrike">
-              <a:solidFill>
-                <a:srgbClr val="000000"/>
-              </a:solidFill>
-              <a:latin typeface="Arial"/>
-            </a:endParaRPr>
-          </a:p>
-          <a:p>
-            <a:pPr lvl="3" marL="1728000" indent="-216000">
-              <a:spcBef>
-                <a:spcPts val="567"/>
-              </a:spcBef>
-              <a:buClr>
-                <a:srgbClr val="000000"/>
-              </a:buClr>
-              <a:buSzPct val="75000"/>
-              <a:buFont typeface="Symbol" charset="2"/>
-              <a:buChar char=""/>
-            </a:pPr>
-            <a:r>
-              <a:rPr b="0" lang="en-US" sz="1400" spc="-1" strike="noStrike">
-                <a:solidFill>
-                  <a:srgbClr val="000000"/>
-                </a:solidFill>
-                <a:latin typeface="Arial"/>
-              </a:rPr>
-              <a:t>Fourth Outline Level</a:t>
-            </a:r>
-            <a:endParaRPr b="0" lang="en-US" sz="1400" spc="-1" strike="noStrike">
-              <a:solidFill>
-                <a:srgbClr val="000000"/>
-              </a:solidFill>
-              <a:latin typeface="Arial"/>
-            </a:endParaRPr>
-          </a:p>
-          <a:p>
-            <a:pPr lvl="4" marL="2160000" indent="-216000">
-              <a:spcBef>
-                <a:spcPts val="283"/>
-              </a:spcBef>
-              <a:buClr>
-                <a:srgbClr val="000000"/>
-              </a:buClr>
-              <a:buSzPct val="45000"/>
-              <a:buFont typeface="Wingdings" charset="2"/>
-              <a:buChar char=""/>
-            </a:pPr>
-            <a:r>
-              <a:rPr b="0" lang="en-US" sz="1400" spc="-1" strike="noStrike">
-                <a:solidFill>
-                  <a:srgbClr val="000000"/>
-                </a:solidFill>
-                <a:latin typeface="Arial"/>
-              </a:rPr>
-              <a:t>Fifth Outline Level</a:t>
-            </a:r>
-            <a:endParaRPr b="0" lang="en-US" sz="1400" spc="-1" strike="noStrike">
-              <a:solidFill>
-                <a:srgbClr val="000000"/>
-              </a:solidFill>
-              <a:latin typeface="Arial"/>
-            </a:endParaRPr>
-          </a:p>
-          <a:p>
-            <a:pPr lvl="5" marL="2592000" indent="-216000">
-              <a:spcBef>
-                <a:spcPts val="283"/>
-              </a:spcBef>
-              <a:buClr>
-                <a:srgbClr val="000000"/>
-              </a:buClr>
-              <a:buSzPct val="45000"/>
-              <a:buFont typeface="Wingdings" charset="2"/>
-              <a:buChar char=""/>
-            </a:pPr>
-            <a:r>
-              <a:rPr b="0" lang="en-US" sz="1400" spc="-1" strike="noStrike">
-                <a:solidFill>
-                  <a:srgbClr val="000000"/>
-                </a:solidFill>
-                <a:latin typeface="Arial"/>
-              </a:rPr>
-              <a:t>Sixth Outline Level</a:t>
-            </a:r>
-            <a:endParaRPr b="0" lang="en-US" sz="1400" spc="-1" strike="noStrike">
-              <a:solidFill>
-                <a:srgbClr val="000000"/>
-              </a:solidFill>
-              <a:latin typeface="Arial"/>
-            </a:endParaRPr>
-          </a:p>
-          <a:p>
-            <a:pPr lvl="6" marL="3024000" indent="-216000">
-              <a:spcBef>
-                <a:spcPts val="283"/>
-              </a:spcBef>
-              <a:buClr>
-                <a:srgbClr val="000000"/>
-              </a:buClr>
-              <a:buSzPct val="45000"/>
-              <a:buFont typeface="Wingdings" charset="2"/>
-              <a:buChar char=""/>
-            </a:pPr>
-            <a:r>
-              <a:rPr b="0" lang="en-US" sz="1400" spc="-1" strike="noStrike">
-                <a:solidFill>
-                  <a:srgbClr val="000000"/>
-                </a:solidFill>
-                <a:latin typeface="Arial"/>
-              </a:rPr>
-              <a:t>Seventh Outline Level</a:t>
-            </a:r>
-            <a:endParaRPr b="0" lang="en-US" sz="1400" spc="-1" strike="noStrike">
               <a:solidFill>
                 <a:srgbClr val="000000"/>
               </a:solidFill>
@@ -2301,7 +1402,7 @@
       </p:sp>
       <p:pic>
         <p:nvPicPr>
-          <p:cNvPr id="12" name="Google Shape;26;p2" descr=""/>
+          <p:cNvPr id="8" name="Google Shape;26;p2" descr=""/>
           <p:cNvPicPr/>
           <p:nvPr/>
         </p:nvPicPr>
@@ -2312,7 +1413,7 @@
         <p:spPr>
           <a:xfrm>
             <a:off x="-11880" y="4593600"/>
-            <a:ext cx="2140920" cy="467640"/>
+            <a:ext cx="2140560" cy="467280"/>
           </a:xfrm>
           <a:prstGeom prst="rect">
             <a:avLst/>
@@ -2324,14 +1425,14 @@
       </p:pic>
       <p:sp>
         <p:nvSpPr>
-          <p:cNvPr id="13" name="Google Shape;29;p2"/>
+          <p:cNvPr id="9" name="Google Shape;29;p2"/>
           <p:cNvSpPr/>
           <p:nvPr/>
         </p:nvSpPr>
         <p:spPr>
           <a:xfrm>
             <a:off x="8638560" y="52200"/>
-            <a:ext cx="448920" cy="445320"/>
+            <a:ext cx="448560" cy="444960"/>
           </a:xfrm>
           <a:prstGeom prst="ellipse">
             <a:avLst/>
@@ -2353,7 +1454,7 @@
           <a:fontRef idx="minor"/>
         </p:style>
         <p:txBody>
-          <a:bodyPr tIns="91440" bIns="91440" anchor="ctr">
+          <a:bodyPr lIns="90000" rIns="90000" tIns="91440" bIns="91440" anchor="ctr">
             <a:noAutofit/>
           </a:bodyPr>
           <a:p>
@@ -2377,14 +1478,14 @@
       </p:sp>
       <p:cxnSp>
         <p:nvCxnSpPr>
-          <p:cNvPr id="14" name="Google Shape;30;p2"/>
+          <p:cNvPr id="10" name="Google Shape;30;p2"/>
           <p:cNvCxnSpPr/>
           <p:nvPr/>
         </p:nvCxnSpPr>
         <p:spPr>
           <a:xfrm flipH="1">
             <a:off x="7560" y="4623840"/>
-            <a:ext cx="4564800" cy="360"/>
+            <a:ext cx="4565160" cy="720"/>
           </a:xfrm>
           <a:prstGeom prst="straightConnector1">
             <a:avLst/>
@@ -2399,14 +1500,14 @@
       </p:cxnSp>
       <p:cxnSp>
         <p:nvCxnSpPr>
-          <p:cNvPr id="15" name="Google Shape;31;p2"/>
+          <p:cNvPr id="11" name="Google Shape;31;p2"/>
           <p:cNvCxnSpPr/>
           <p:nvPr/>
         </p:nvCxnSpPr>
         <p:spPr>
           <a:xfrm flipH="1">
             <a:off x="4575600" y="4623840"/>
-            <a:ext cx="4564800" cy="360"/>
+            <a:ext cx="4565160" cy="720"/>
           </a:xfrm>
           <a:prstGeom prst="straightConnector1">
             <a:avLst/>
@@ -2419,6 +1520,280 @@
           </a:ln>
         </p:spPr>
       </p:cxnSp>
+      <p:sp>
+        <p:nvSpPr>
+          <p:cNvPr id="12" name="PlaceHolder 1"/>
+          <p:cNvSpPr>
+            <a:spLocks noGrp="1"/>
+          </p:cNvSpPr>
+          <p:nvPr>
+            <p:ph type="title"/>
+          </p:nvPr>
+        </p:nvSpPr>
+        <p:spPr>
+          <a:xfrm>
+            <a:off x="457200" y="205200"/>
+            <a:ext cx="8229240" cy="858600"/>
+          </a:xfrm>
+          <a:prstGeom prst="rect">
+            <a:avLst/>
+          </a:prstGeom>
+          <a:noFill/>
+          <a:ln w="0">
+            <a:noFill/>
+          </a:ln>
+        </p:spPr>
+        <p:txBody>
+          <a:bodyPr lIns="0" rIns="0" tIns="0" bIns="0" anchor="ctr">
+            <a:noAutofit/>
+          </a:bodyPr>
+          <a:p>
+            <a:pPr indent="0" algn="ctr">
+              <a:buNone/>
+            </a:pPr>
+            <a:r>
+              <a:rPr b="0" lang="en-US" sz="4400" spc="-1" strike="noStrike">
+                <a:solidFill>
+                  <a:srgbClr val="000000"/>
+                </a:solidFill>
+                <a:latin typeface="Arial"/>
+              </a:rPr>
+              <a:t>Click to edit the title text format</a:t>
+            </a:r>
+            <a:endParaRPr b="0" lang="en-US" sz="4400" spc="-1" strike="noStrike">
+              <a:solidFill>
+                <a:srgbClr val="000000"/>
+              </a:solidFill>
+              <a:latin typeface="Arial"/>
+            </a:endParaRPr>
+          </a:p>
+        </p:txBody>
+      </p:sp>
+      <p:sp>
+        <p:nvSpPr>
+          <p:cNvPr id="13" name="PlaceHolder 2"/>
+          <p:cNvSpPr>
+            <a:spLocks noGrp="1"/>
+          </p:cNvSpPr>
+          <p:nvPr>
+            <p:ph type="body"/>
+          </p:nvPr>
+        </p:nvSpPr>
+        <p:spPr>
+          <a:xfrm>
+            <a:off x="457200" y="1203480"/>
+            <a:ext cx="8229240" cy="2982960"/>
+          </a:xfrm>
+          <a:prstGeom prst="rect">
+            <a:avLst/>
+          </a:prstGeom>
+          <a:noFill/>
+          <a:ln w="0">
+            <a:noFill/>
+          </a:ln>
+        </p:spPr>
+        <p:txBody>
+          <a:bodyPr lIns="0" rIns="0" tIns="0" bIns="0" anchor="t">
+            <a:normAutofit/>
+          </a:bodyPr>
+          <a:p>
+            <a:pPr marL="432000" indent="-324000">
+              <a:spcBef>
+                <a:spcPts val="1417"/>
+              </a:spcBef>
+              <a:buClr>
+                <a:srgbClr val="000000"/>
+              </a:buClr>
+              <a:buSzPct val="45000"/>
+              <a:buFont typeface="Wingdings" charset="2"/>
+              <a:buChar char=""/>
+            </a:pPr>
+            <a:r>
+              <a:rPr b="0" lang="en-US" sz="3200" spc="-1" strike="noStrike">
+                <a:solidFill>
+                  <a:srgbClr val="000000"/>
+                </a:solidFill>
+                <a:latin typeface="Arial"/>
+              </a:rPr>
+              <a:t>Click to edit the outline text format</a:t>
+            </a:r>
+            <a:endParaRPr b="0" lang="en-US" sz="3200" spc="-1" strike="noStrike">
+              <a:solidFill>
+                <a:srgbClr val="000000"/>
+              </a:solidFill>
+              <a:latin typeface="Arial"/>
+            </a:endParaRPr>
+          </a:p>
+          <a:p>
+            <a:pPr lvl="1" marL="864000" indent="-324000">
+              <a:spcBef>
+                <a:spcPts val="1134"/>
+              </a:spcBef>
+              <a:buClr>
+                <a:srgbClr val="000000"/>
+              </a:buClr>
+              <a:buSzPct val="75000"/>
+              <a:buFont typeface="Symbol" charset="2"/>
+              <a:buChar char=""/>
+            </a:pPr>
+            <a:r>
+              <a:rPr b="0" lang="en-US" sz="2800" spc="-1" strike="noStrike">
+                <a:solidFill>
+                  <a:srgbClr val="000000"/>
+                </a:solidFill>
+                <a:latin typeface="Arial"/>
+              </a:rPr>
+              <a:t>Second Outline Level</a:t>
+            </a:r>
+            <a:endParaRPr b="0" lang="en-US" sz="2800" spc="-1" strike="noStrike">
+              <a:solidFill>
+                <a:srgbClr val="000000"/>
+              </a:solidFill>
+              <a:latin typeface="Arial"/>
+            </a:endParaRPr>
+          </a:p>
+          <a:p>
+            <a:pPr lvl="2" marL="1296000" indent="-288000">
+              <a:spcBef>
+                <a:spcPts val="850"/>
+              </a:spcBef>
+              <a:buClr>
+                <a:srgbClr val="000000"/>
+              </a:buClr>
+              <a:buSzPct val="45000"/>
+              <a:buFont typeface="Wingdings" charset="2"/>
+              <a:buChar char=""/>
+            </a:pPr>
+            <a:r>
+              <a:rPr b="0" lang="en-US" sz="2400" spc="-1" strike="noStrike">
+                <a:solidFill>
+                  <a:srgbClr val="000000"/>
+                </a:solidFill>
+                <a:latin typeface="Arial"/>
+              </a:rPr>
+              <a:t>Third Outline Level</a:t>
+            </a:r>
+            <a:endParaRPr b="0" lang="en-US" sz="2400" spc="-1" strike="noStrike">
+              <a:solidFill>
+                <a:srgbClr val="000000"/>
+              </a:solidFill>
+              <a:latin typeface="Arial"/>
+            </a:endParaRPr>
+          </a:p>
+          <a:p>
+            <a:pPr lvl="3" marL="1728000" indent="-216000">
+              <a:spcBef>
+                <a:spcPts val="567"/>
+              </a:spcBef>
+              <a:buClr>
+                <a:srgbClr val="000000"/>
+              </a:buClr>
+              <a:buSzPct val="75000"/>
+              <a:buFont typeface="Symbol" charset="2"/>
+              <a:buChar char=""/>
+            </a:pPr>
+            <a:r>
+              <a:rPr b="0" lang="en-US" sz="2000" spc="-1" strike="noStrike">
+                <a:solidFill>
+                  <a:srgbClr val="000000"/>
+                </a:solidFill>
+                <a:latin typeface="Arial"/>
+              </a:rPr>
+              <a:t>Fourth Outline Level</a:t>
+            </a:r>
+            <a:endParaRPr b="0" lang="en-US" sz="2000" spc="-1" strike="noStrike">
+              <a:solidFill>
+                <a:srgbClr val="000000"/>
+              </a:solidFill>
+              <a:latin typeface="Arial"/>
+            </a:endParaRPr>
+          </a:p>
+          <a:p>
+            <a:pPr lvl="4" marL="2160000" indent="-216000">
+              <a:spcBef>
+                <a:spcPts val="283"/>
+              </a:spcBef>
+              <a:buClr>
+                <a:srgbClr val="000000"/>
+              </a:buClr>
+              <a:buSzPct val="45000"/>
+              <a:buFont typeface="Wingdings" charset="2"/>
+              <a:buChar char=""/>
+            </a:pPr>
+            <a:r>
+              <a:rPr b="0" lang="en-US" sz="2000" spc="-1" strike="noStrike">
+                <a:solidFill>
+                  <a:srgbClr val="000000"/>
+                </a:solidFill>
+                <a:latin typeface="Arial"/>
+              </a:rPr>
+              <a:t>Fifth Outline Level</a:t>
+            </a:r>
+            <a:endParaRPr b="0" lang="en-US" sz="2000" spc="-1" strike="noStrike">
+              <a:solidFill>
+                <a:srgbClr val="000000"/>
+              </a:solidFill>
+              <a:latin typeface="Arial"/>
+            </a:endParaRPr>
+          </a:p>
+          <a:p>
+            <a:pPr lvl="5" marL="2592000" indent="-216000">
+              <a:spcBef>
+                <a:spcPts val="283"/>
+              </a:spcBef>
+              <a:buClr>
+                <a:srgbClr val="000000"/>
+              </a:buClr>
+              <a:buSzPct val="45000"/>
+              <a:buFont typeface="Wingdings" charset="2"/>
+              <a:buChar char=""/>
+            </a:pPr>
+            <a:r>
+              <a:rPr b="0" lang="en-US" sz="2000" spc="-1" strike="noStrike">
+                <a:solidFill>
+                  <a:srgbClr val="000000"/>
+                </a:solidFill>
+                <a:latin typeface="Arial"/>
+              </a:rPr>
+              <a:t>Sixth Outline Level</a:t>
+            </a:r>
+            <a:endParaRPr b="0" lang="en-US" sz="2000" spc="-1" strike="noStrike">
+              <a:solidFill>
+                <a:srgbClr val="000000"/>
+              </a:solidFill>
+              <a:latin typeface="Arial"/>
+            </a:endParaRPr>
+          </a:p>
+          <a:p>
+            <a:pPr lvl="6" marL="3024000" indent="-216000">
+              <a:spcBef>
+                <a:spcPts val="283"/>
+              </a:spcBef>
+              <a:buClr>
+                <a:srgbClr val="000000"/>
+              </a:buClr>
+              <a:buSzPct val="45000"/>
+              <a:buFont typeface="Wingdings" charset="2"/>
+              <a:buChar char=""/>
+            </a:pPr>
+            <a:r>
+              <a:rPr b="0" lang="en-US" sz="2000" spc="-1" strike="noStrike">
+                <a:solidFill>
+                  <a:srgbClr val="000000"/>
+                </a:solidFill>
+                <a:latin typeface="Arial"/>
+              </a:rPr>
+              <a:t>Seventh Outline Level</a:t>
+            </a:r>
+            <a:endParaRPr b="0" lang="en-US" sz="2000" spc="-1" strike="noStrike">
+              <a:solidFill>
+                <a:srgbClr val="000000"/>
+              </a:solidFill>
+              <a:latin typeface="Arial"/>
+            </a:endParaRPr>
+          </a:p>
+        </p:txBody>
+      </p:sp>
     </p:spTree>
   </p:cSld>
   <p:clrMap bg1="lt1" bg2="lt2" tx1="dk1" tx2="dk2" accent1="accent1" accent2="accent2" accent3="accent3" accent4="accent4" accent5="accent5" accent6="accent6" hlink="hlink" folHlink="folHlink"/>
@@ -2447,7 +1822,7 @@
       </p:grpSpPr>
       <p:sp>
         <p:nvSpPr>
-          <p:cNvPr id="22" name="PlaceHolder 1"/>
+          <p:cNvPr id="20" name="PlaceHolder 1"/>
           <p:cNvSpPr>
             <a:spLocks noGrp="1"/>
           </p:cNvSpPr>
@@ -2458,7 +1833,7 @@
         <p:spPr>
           <a:xfrm>
             <a:off x="-11880" y="864000"/>
-            <a:ext cx="4571640" cy="1701720"/>
+            <a:ext cx="4571280" cy="1701360"/>
           </a:xfrm>
           <a:prstGeom prst="rect">
             <a:avLst/>
@@ -2484,44 +1859,80 @@
               <a:buChar char="-"/>
             </a:pPr>
             <a:r>
-              <a:rPr b="0" lang="en" sz="1400" spc="-1" strike="noStrike">
+              <a:rPr b="0" lang="en" sz="1100" spc="-1" strike="noStrike">
                 <a:solidFill>
                   <a:srgbClr val="000000"/>
                 </a:solidFill>
                 <a:latin typeface="Arial"/>
                 <a:ea typeface="Arial"/>
               </a:rPr>
-              <a:t>Onboarded new members</a:t>
-            </a:r>
-            <a:endParaRPr b="0" lang="en-US" sz="1400" spc="-1" strike="noStrike">
-              <a:solidFill>
-                <a:srgbClr val="000000"/>
-              </a:solidFill>
-              <a:latin typeface="Arial"/>
-            </a:endParaRPr>
-          </a:p>
-          <a:p>
-            <a:pPr marL="285840" indent="-285840">
-              <a:lnSpc>
-                <a:spcPct val="100000"/>
-              </a:lnSpc>
+              <a:t>Attempted run through of MCT</a:t>
+            </a:r>
+            <a:endParaRPr b="0" lang="en-US" sz="1100" spc="-1" strike="noStrike">
+              <a:solidFill>
+                <a:srgbClr val="000000"/>
+              </a:solidFill>
+              <a:latin typeface="Arial"/>
+            </a:endParaRPr>
+          </a:p>
+          <a:p>
+            <a:pPr lvl="1" marL="864000" indent="-324000">
+              <a:lnSpc>
+                <a:spcPct val="100000"/>
+              </a:lnSpc>
+              <a:spcBef>
+                <a:spcPts val="1134"/>
+              </a:spcBef>
               <a:buClr>
                 <a:srgbClr val="000000"/>
               </a:buClr>
-              <a:buFont typeface="Calibri,Sans-Serif"/>
-              <a:buChar char="-"/>
-            </a:pPr>
-            <a:r>
-              <a:rPr b="0" lang="en" sz="1400" spc="-1" strike="noStrike">
+              <a:buSzPct val="75000"/>
+              <a:buFont typeface="Symbol" charset="2"/>
+              <a:buChar char=""/>
+            </a:pPr>
+            <a:r>
+              <a:rPr b="0" lang="en" sz="1100" spc="-1" strike="noStrike">
                 <a:solidFill>
                   <a:srgbClr val="000000"/>
                 </a:solidFill>
                 <a:latin typeface="Arial"/>
                 <a:ea typeface="Arial"/>
               </a:rPr>
-              <a:t>Settled on a ground station architecture</a:t>
-            </a:r>
-            <a:endParaRPr b="0" lang="en-US" sz="1400" spc="-1" strike="noStrike">
+              <a:t>Figured out where things are</a:t>
+            </a:r>
+            <a:endParaRPr b="0" lang="en-US" sz="1100" spc="-1" strike="noStrike">
+              <a:solidFill>
+                <a:srgbClr val="000000"/>
+              </a:solidFill>
+              <a:latin typeface="Arial"/>
+            </a:endParaRPr>
+          </a:p>
+          <a:p>
+            <a:pPr lvl="1" marL="864000" indent="-324000">
+              <a:lnSpc>
+                <a:spcPct val="100000"/>
+              </a:lnSpc>
+              <a:spcBef>
+                <a:spcPts val="1134"/>
+              </a:spcBef>
+              <a:buClr>
+                <a:srgbClr val="000000"/>
+              </a:buClr>
+              <a:buSzPct val="75000"/>
+              <a:buFont typeface="Symbol" charset="2"/>
+              <a:buChar char=""/>
+            </a:pPr>
+            <a:r>
+              <a:rPr b="0" lang="en" sz="1100" spc="-1" strike="noStrike">
+                <a:solidFill>
+                  <a:srgbClr val="000000"/>
+                </a:solidFill>
+                <a:latin typeface="Arial"/>
+                <a:ea typeface="Arial"/>
+              </a:rPr>
+              <a:t>And where documentation is</a:t>
+            </a:r>
+            <a:endParaRPr b="0" lang="en-US" sz="1100" spc="-1" strike="noStrike">
               <a:solidFill>
                 <a:srgbClr val="000000"/>
               </a:solidFill>
@@ -2530,20 +1941,6 @@
           </a:p>
           <a:p>
             <a:pPr indent="0">
-              <a:lnSpc>
-                <a:spcPct val="100000"/>
-              </a:lnSpc>
-              <a:buNone/>
-            </a:pPr>
-            <a:endParaRPr b="0" lang="en-US" sz="1400" spc="-1" strike="noStrike">
-              <a:solidFill>
-                <a:srgbClr val="000000"/>
-              </a:solidFill>
-              <a:latin typeface="Arial"/>
-            </a:endParaRPr>
-          </a:p>
-          <a:p>
-            <a:pPr marL="425520" indent="0">
               <a:lnSpc>
                 <a:spcPct val="100000"/>
               </a:lnSpc>
@@ -2560,7 +1957,7 @@
             </a:endParaRPr>
           </a:p>
           <a:p>
-            <a:pPr indent="0">
+            <a:pPr marL="425520" indent="0">
               <a:lnSpc>
                 <a:spcPct val="100000"/>
               </a:lnSpc>
@@ -2577,7 +1974,7 @@
             </a:endParaRPr>
           </a:p>
           <a:p>
-            <a:pPr indent="0">
+            <a:pPr marL="425520" indent="0">
               <a:lnSpc>
                 <a:spcPct val="100000"/>
               </a:lnSpc>
@@ -2594,7 +1991,7 @@
             </a:endParaRPr>
           </a:p>
           <a:p>
-            <a:pPr indent="0">
+            <a:pPr marL="425520" indent="0">
               <a:lnSpc>
                 <a:spcPct val="100000"/>
               </a:lnSpc>
@@ -2603,15 +2000,15 @@
                 <a:tab algn="l" pos="0"/>
               </a:tabLst>
             </a:pPr>
-            <a:endParaRPr b="0" lang="en-US" sz="1100" spc="-1" strike="noStrike">
-              <a:solidFill>
-                <a:srgbClr val="000000"/>
-              </a:solidFill>
-              <a:latin typeface="Arial"/>
-            </a:endParaRPr>
-          </a:p>
-          <a:p>
-            <a:pPr indent="0">
+            <a:endParaRPr b="0" lang="en-US" sz="1400" spc="-1" strike="noStrike">
+              <a:solidFill>
+                <a:srgbClr val="000000"/>
+              </a:solidFill>
+              <a:latin typeface="Arial"/>
+            </a:endParaRPr>
+          </a:p>
+          <a:p>
+            <a:pPr marL="425520" indent="0">
               <a:lnSpc>
                 <a:spcPct val="100000"/>
               </a:lnSpc>
@@ -2620,15 +2017,15 @@
                 <a:tab algn="l" pos="0"/>
               </a:tabLst>
             </a:pPr>
-            <a:endParaRPr b="0" lang="en-US" sz="1400" spc="-1" strike="noStrike">
-              <a:solidFill>
-                <a:srgbClr val="000000"/>
-              </a:solidFill>
-              <a:latin typeface="Arial"/>
-            </a:endParaRPr>
-          </a:p>
-          <a:p>
-            <a:pPr indent="0">
+            <a:endParaRPr b="0" lang="en-US" sz="1100" spc="-1" strike="noStrike">
+              <a:solidFill>
+                <a:srgbClr val="000000"/>
+              </a:solidFill>
+              <a:latin typeface="Arial"/>
+            </a:endParaRPr>
+          </a:p>
+          <a:p>
+            <a:pPr marL="425520" indent="0">
               <a:lnSpc>
                 <a:spcPct val="100000"/>
               </a:lnSpc>
@@ -2644,11 +2041,28 @@
               <a:latin typeface="Arial"/>
             </a:endParaRPr>
           </a:p>
+          <a:p>
+            <a:pPr marL="425520" indent="0">
+              <a:lnSpc>
+                <a:spcPct val="100000"/>
+              </a:lnSpc>
+              <a:buNone/>
+              <a:tabLst>
+                <a:tab algn="l" pos="0"/>
+              </a:tabLst>
+            </a:pPr>
+            <a:endParaRPr b="0" lang="en-US" sz="1400" spc="-1" strike="noStrike">
+              <a:solidFill>
+                <a:srgbClr val="000000"/>
+              </a:solidFill>
+              <a:latin typeface="Arial"/>
+            </a:endParaRPr>
+          </a:p>
         </p:txBody>
       </p:sp>
       <p:sp>
         <p:nvSpPr>
-          <p:cNvPr id="23" name="PlaceHolder 2"/>
+          <p:cNvPr id="21" name="PlaceHolder 2"/>
           <p:cNvSpPr>
             <a:spLocks noGrp="1"/>
           </p:cNvSpPr>
@@ -2659,7 +2073,7 @@
         <p:spPr>
           <a:xfrm>
             <a:off x="4572000" y="864000"/>
-            <a:ext cx="4571640" cy="1701720"/>
+            <a:ext cx="4571280" cy="1701360"/>
           </a:xfrm>
           <a:prstGeom prst="rect">
             <a:avLst/>
@@ -2692,7 +2106,35 @@
                 <a:latin typeface="Arial"/>
                 <a:ea typeface="Arial"/>
               </a:rPr>
-              <a:t>No</a:t>
+              <a:t>HFSS machine in 443 is offline and can’t be logged in</a:t>
+            </a:r>
+            <a:endParaRPr b="0" lang="en-US" sz="1400" spc="-1" strike="noStrike">
+              <a:solidFill>
+                <a:srgbClr val="000000"/>
+              </a:solidFill>
+              <a:latin typeface="Arial"/>
+            </a:endParaRPr>
+          </a:p>
+          <a:p>
+            <a:pPr marL="457200" indent="-317520">
+              <a:lnSpc>
+                <a:spcPct val="100000"/>
+              </a:lnSpc>
+              <a:buClr>
+                <a:srgbClr val="000000"/>
+              </a:buClr>
+              <a:buFont typeface="Arial"/>
+              <a:buChar char="●"/>
+            </a:pPr>
+            <a:r>
+              <a:rPr b="0" lang="en" sz="1400" spc="-1" strike="noStrike">
+                <a:solidFill>
+                  <a:srgbClr val="000000"/>
+                </a:solidFill>
+                <a:latin typeface="Arial"/>
+                <a:ea typeface="Arial"/>
+              </a:rPr>
+              <a:t>Waiting on meeting with Dhruva for more details about test setup</a:t>
             </a:r>
             <a:endParaRPr b="0" lang="en-US" sz="1400" spc="-1" strike="noStrike">
               <a:solidFill>
@@ -2705,7 +2147,7 @@
       </p:sp>
       <p:sp>
         <p:nvSpPr>
-          <p:cNvPr id="24" name="PlaceHolder 3"/>
+          <p:cNvPr id="22" name="PlaceHolder 3"/>
           <p:cNvSpPr>
             <a:spLocks noGrp="1"/>
           </p:cNvSpPr>
@@ -2716,7 +2158,7 @@
         <p:spPr>
           <a:xfrm>
             <a:off x="4572000" y="2845800"/>
-            <a:ext cx="4571640" cy="1701720"/>
+            <a:ext cx="4571280" cy="1701360"/>
           </a:xfrm>
           <a:prstGeom prst="rect">
             <a:avLst/>
@@ -2737,19 +2179,18 @@
               </a:spcBef>
               <a:buNone/>
             </a:pPr>
-            <a:endParaRPr b="0" lang="en-US" sz="1400" spc="-1" strike="noStrike">
-              <a:solidFill>
-                <a:srgbClr val="000000"/>
-              </a:solidFill>
-              <a:latin typeface="Arial"/>
-              <a:ea typeface="Arial"/>
+            <a:endParaRPr b="0" lang="en-US" sz="1800" spc="-1" strike="noStrike">
+              <a:solidFill>
+                <a:srgbClr val="000000"/>
+              </a:solidFill>
+              <a:latin typeface="Arial"/>
             </a:endParaRPr>
           </a:p>
         </p:txBody>
       </p:sp>
       <p:sp>
         <p:nvSpPr>
-          <p:cNvPr id="25" name="PlaceHolder 4"/>
+          <p:cNvPr id="23" name="PlaceHolder 4"/>
           <p:cNvSpPr>
             <a:spLocks noGrp="1"/>
           </p:cNvSpPr>
@@ -2760,7 +2201,7 @@
         <p:spPr>
           <a:xfrm>
             <a:off x="-4320" y="2845800"/>
-            <a:ext cx="4571640" cy="1850400"/>
+            <a:ext cx="4571280" cy="1850040"/>
           </a:xfrm>
           <a:prstGeom prst="rect">
             <a:avLst/>
@@ -2793,7 +2234,39 @@
                 <a:latin typeface="Arial"/>
                 <a:ea typeface="Arial"/>
               </a:rPr>
-              <a:t>Setting up new gnd station laptop</a:t>
+              <a:t>Meeting with Dhruva, reviewing documentation about test setups and Lithium Pins</a:t>
+            </a:r>
+            <a:endParaRPr b="0" lang="en-US" sz="1400" spc="-1" strike="noStrike">
+              <a:solidFill>
+                <a:srgbClr val="000000"/>
+              </a:solidFill>
+              <a:latin typeface="Arial"/>
+            </a:endParaRPr>
+          </a:p>
+          <a:p>
+            <a:pPr lvl="1" marL="864000" indent="-324000">
+              <a:lnSpc>
+                <a:spcPct val="100000"/>
+              </a:lnSpc>
+              <a:spcBef>
+                <a:spcPts val="1134"/>
+              </a:spcBef>
+              <a:buClr>
+                <a:srgbClr val="000000"/>
+              </a:buClr>
+              <a:buSzPct val="75000"/>
+              <a:buFont typeface="Symbol" charset="2"/>
+              <a:buChar char=""/>
+            </a:pPr>
+            <a:r>
+              <a:rPr b="0" lang="en-US" sz="1400" spc="-1" strike="noStrike">
+                <a:solidFill>
+                  <a:schemeClr val="dk1"/>
+                </a:solidFill>
+                <a:latin typeface="Arial"/>
+                <a:ea typeface="Arial"/>
+              </a:rPr>
+              <a:t>After that aim to get MCT bench setup</a:t>
             </a:r>
             <a:endParaRPr b="0" lang="en-US" sz="1400" spc="-1" strike="noStrike">
               <a:solidFill>
@@ -2821,7 +2294,7 @@
                 <a:latin typeface="Arial"/>
                 <a:ea typeface="Arial"/>
               </a:rPr>
-              <a:t>Setting up 443 machine</a:t>
+              <a:t>Install hydra on the 443 machine</a:t>
             </a:r>
             <a:endParaRPr b="0" lang="en-US" sz="1400" spc="-1" strike="noStrike">
               <a:solidFill>
@@ -2849,7 +2322,7 @@
                 <a:latin typeface="Arial"/>
                 <a:ea typeface="Arial"/>
               </a:rPr>
-              <a:t>MCT documentation read through</a:t>
+              <a:t>More freshman to onboard</a:t>
             </a:r>
             <a:endParaRPr b="0" lang="en-US" sz="1400" spc="-1" strike="noStrike">
               <a:solidFill>
@@ -2859,26 +2332,15 @@
             </a:endParaRPr>
           </a:p>
           <a:p>
-            <a:pPr marL="457200" indent="-317520">
-              <a:lnSpc>
-                <a:spcPct val="100000"/>
-              </a:lnSpc>
-              <a:buClr>
-                <a:srgbClr val="000000"/>
-              </a:buClr>
-              <a:buFont typeface="Calibri,Sans-Serif"/>
-              <a:buChar char="-"/>
-            </a:pPr>
-            <a:r>
-              <a:rPr b="0" lang="en-US" sz="1400" spc="-1" strike="noStrike">
-                <a:solidFill>
-                  <a:schemeClr val="dk1"/>
-                </a:solidFill>
-                <a:latin typeface="Arial"/>
-                <a:ea typeface="Arial"/>
-              </a:rPr>
-              <a:t>Aim to have MCT bench setup</a:t>
-            </a:r>
+            <a:pPr indent="0">
+              <a:lnSpc>
+                <a:spcPct val="100000"/>
+              </a:lnSpc>
+              <a:buNone/>
+              <a:tabLst>
+                <a:tab algn="l" pos="0"/>
+              </a:tabLst>
+            </a:pPr>
             <a:endParaRPr b="0" lang="en-US" sz="1400" spc="-1" strike="noStrike">
               <a:solidFill>
                 <a:srgbClr val="000000"/>
@@ -2892,6 +2354,9 @@
                 <a:spcPct val="100000"/>
               </a:lnSpc>
               <a:buNone/>
+              <a:tabLst>
+                <a:tab algn="l" pos="0"/>
+              </a:tabLst>
             </a:pPr>
             <a:endParaRPr b="0" lang="en-US" sz="1400" spc="-1" strike="noStrike">
               <a:solidFill>
@@ -2906,6 +2371,9 @@
                 <a:spcPct val="100000"/>
               </a:lnSpc>
               <a:buNone/>
+              <a:tabLst>
+                <a:tab algn="l" pos="0"/>
+              </a:tabLst>
             </a:pPr>
             <a:endParaRPr b="0" lang="en-US" sz="1400" spc="-1" strike="noStrike">
               <a:solidFill>
@@ -2920,20 +2388,9 @@
                 <a:spcPct val="100000"/>
               </a:lnSpc>
               <a:buNone/>
-            </a:pPr>
-            <a:endParaRPr b="0" lang="en-US" sz="1400" spc="-1" strike="noStrike">
-              <a:solidFill>
-                <a:srgbClr val="000000"/>
-              </a:solidFill>
-              <a:latin typeface="Arial"/>
-            </a:endParaRPr>
-          </a:p>
-          <a:p>
-            <a:pPr indent="0">
-              <a:lnSpc>
-                <a:spcPct val="100000"/>
-              </a:lnSpc>
-              <a:buNone/>
+              <a:tabLst>
+                <a:tab algn="l" pos="0"/>
+              </a:tabLst>
             </a:pPr>
             <a:endParaRPr b="0" lang="en-US" sz="1400" spc="-1" strike="noStrike">
               <a:solidFill>
@@ -2946,7 +2403,7 @@
       </p:sp>
       <p:sp>
         <p:nvSpPr>
-          <p:cNvPr id="26" name="PlaceHolder 5"/>
+          <p:cNvPr id="24" name="PlaceHolder 5"/>
           <p:cNvSpPr>
             <a:spLocks noGrp="1"/>
           </p:cNvSpPr>
@@ -2957,7 +2414,7 @@
         <p:spPr>
           <a:xfrm>
             <a:off x="6306120" y="-11880"/>
-            <a:ext cx="2266200" cy="573480"/>
+            <a:ext cx="2265840" cy="573120"/>
           </a:xfrm>
           <a:prstGeom prst="rect">
             <a:avLst/>
@@ -2977,6 +2434,9 @@
                 <a:spcPct val="100000"/>
               </a:lnSpc>
               <a:buNone/>
+              <a:tabLst>
+                <a:tab algn="l" pos="0"/>
+              </a:tabLst>
             </a:pPr>
             <a:r>
               <a:rPr b="0" lang="en" sz="1400" spc="-1" strike="noStrike">
@@ -2986,7 +2446,7 @@
                 <a:latin typeface="Arial"/>
                 <a:ea typeface="Arial"/>
               </a:rPr>
-              <a:t>Justin Le 9/11/2026</a:t>
+              <a:t>Justin Le 9/18/2026</a:t>
             </a:r>
             <a:endParaRPr b="0" lang="en-US" sz="1400" spc="-1" strike="noStrike">
               <a:solidFill>
@@ -2999,13 +2459,13 @@
       </p:sp>
       <p:graphicFrame>
         <p:nvGraphicFramePr>
-          <p:cNvPr id="27" name="Table 3"/>
+          <p:cNvPr id="25" name="Table 3"/>
           <p:cNvGraphicFramePr/>
           <p:nvPr/>
         </p:nvGraphicFramePr>
         <p:xfrm>
           <a:off x="4604400" y="2577600"/>
-          <a:ext cx="4539240" cy="2040480"/>
+          <a:ext cx="4538160" cy="2040120"/>
         </p:xfrm>
         <a:graphic>
           <a:graphicData uri="http://schemas.openxmlformats.org/drawingml/2006/table">
@@ -3452,7 +2912,7 @@
                           <a:latin typeface="Arial"/>
                           <a:ea typeface="Arial"/>
                         </a:rPr>
-                        <a:t>10hrs</a:t>
+                        <a:t>8hrs</a:t>
                       </a:r>
                       <a:endParaRPr b="0" lang="en-US" sz="1000" spc="-1" strike="noStrike">
                         <a:solidFill>
@@ -3500,6 +2960,11 @@
                       <a:noAutofit/>
                     </a:bodyPr>
                     <a:p>
+                      <a:pPr>
+                        <a:lnSpc>
+                          <a:spcPct val="100000"/>
+                        </a:lnSpc>
+                      </a:pPr>
                       <a:r>
                         <a:rPr b="0" lang="en-US" sz="1000" spc="-1" strike="noStrike">
                           <a:solidFill>
@@ -3514,7 +2979,6 @@
                           <a:srgbClr val="000000"/>
                         </a:solidFill>
                         <a:latin typeface="Arial"/>
-                        <a:ea typeface="Arial"/>
                       </a:endParaRPr>
                     </a:p>
                   </a:txBody>
@@ -3554,7 +3018,11 @@
                       <a:noAutofit/>
                     </a:bodyPr>
                     <a:p>
-                      <a:pPr algn="ctr"/>
+                      <a:pPr algn="ctr">
+                        <a:lnSpc>
+                          <a:spcPct val="100000"/>
+                        </a:lnSpc>
+                      </a:pPr>
                       <a:r>
                         <a:rPr b="0" lang="en-US" sz="1000" spc="-1" strike="noStrike">
                           <a:solidFill>
@@ -3569,7 +3037,6 @@
                           <a:srgbClr val="000000"/>
                         </a:solidFill>
                         <a:latin typeface="Arial"/>
-                        <a:ea typeface="Arial"/>
                       </a:endParaRPr>
                     </a:p>
                   </a:txBody>
@@ -3609,7 +3076,11 @@
                       <a:noAutofit/>
                     </a:bodyPr>
                     <a:p>
-                      <a:pPr algn="ctr"/>
+                      <a:pPr algn="ctr">
+                        <a:lnSpc>
+                          <a:spcPct val="100000"/>
+                        </a:lnSpc>
+                      </a:pPr>
                       <a:r>
                         <a:rPr b="0" lang="en-US" sz="1000" spc="-1" strike="noStrike">
                           <a:solidFill>
@@ -3624,7 +3095,6 @@
                           <a:srgbClr val="000000"/>
                         </a:solidFill>
                         <a:latin typeface="Arial"/>
-                        <a:ea typeface="Arial"/>
                       </a:endParaRPr>
                     </a:p>
                   </a:txBody>
@@ -3664,7 +3134,11 @@
                       <a:noAutofit/>
                     </a:bodyPr>
                     <a:p>
-                      <a:pPr algn="ctr"/>
+                      <a:pPr algn="ctr">
+                        <a:lnSpc>
+                          <a:spcPct val="100000"/>
+                        </a:lnSpc>
+                      </a:pPr>
                       <a:r>
                         <a:rPr b="0" lang="en-US" sz="1000" spc="-1" strike="noStrike">
                           <a:solidFill>
@@ -3679,7 +3153,6 @@
                           <a:srgbClr val="000000"/>
                         </a:solidFill>
                         <a:latin typeface="Arial"/>
-                        <a:ea typeface="Arial"/>
                       </a:endParaRPr>
                     </a:p>
                   </a:txBody>
@@ -3721,6 +3194,11 @@
                       <a:noAutofit/>
                     </a:bodyPr>
                     <a:p>
+                      <a:pPr>
+                        <a:lnSpc>
+                          <a:spcPct val="100000"/>
+                        </a:lnSpc>
+                      </a:pPr>
                       <a:r>
                         <a:rPr b="0" lang="en-US" sz="1000" spc="-1" strike="noStrike">
                           <a:solidFill>
@@ -3735,7 +3213,6 @@
                           <a:srgbClr val="000000"/>
                         </a:solidFill>
                         <a:latin typeface="Arial"/>
-                        <a:ea typeface="Arial"/>
                       </a:endParaRPr>
                     </a:p>
                   </a:txBody>
@@ -3775,7 +3252,11 @@
                       <a:noAutofit/>
                     </a:bodyPr>
                     <a:p>
-                      <a:pPr algn="ctr"/>
+                      <a:pPr algn="ctr">
+                        <a:lnSpc>
+                          <a:spcPct val="100000"/>
+                        </a:lnSpc>
+                      </a:pPr>
                       <a:r>
                         <a:rPr b="0" lang="en-US" sz="1000" spc="-1" strike="noStrike">
                           <a:solidFill>
@@ -3790,7 +3271,6 @@
                           <a:srgbClr val="000000"/>
                         </a:solidFill>
                         <a:latin typeface="Arial"/>
-                        <a:ea typeface="Arial"/>
                       </a:endParaRPr>
                     </a:p>
                   </a:txBody>
@@ -3830,7 +3310,11 @@
                       <a:noAutofit/>
                     </a:bodyPr>
                     <a:p>
-                      <a:pPr algn="ctr"/>
+                      <a:pPr algn="ctr">
+                        <a:lnSpc>
+                          <a:spcPct val="100000"/>
+                        </a:lnSpc>
+                      </a:pPr>
                       <a:r>
                         <a:rPr b="0" lang="en-US" sz="1000" spc="-1" strike="noStrike">
                           <a:solidFill>
@@ -3845,7 +3329,6 @@
                           <a:srgbClr val="000000"/>
                         </a:solidFill>
                         <a:latin typeface="Arial"/>
-                        <a:ea typeface="Arial"/>
                       </a:endParaRPr>
                     </a:p>
                   </a:txBody>
@@ -3885,7 +3368,245 @@
                       <a:noAutofit/>
                     </a:bodyPr>
                     <a:p>
-                      <a:pPr algn="ctr"/>
+                      <a:pPr algn="ctr">
+                        <a:lnSpc>
+                          <a:spcPct val="100000"/>
+                        </a:lnSpc>
+                      </a:pPr>
+                      <a:r>
+                        <a:rPr b="0" lang="en-US" sz="1000" spc="-1" strike="noStrike">
+                          <a:solidFill>
+                            <a:srgbClr val="000000"/>
+                          </a:solidFill>
+                          <a:latin typeface="Arial"/>
+                        </a:rPr>
+                        <a:t>26hrs</a:t>
+                      </a:r>
+                      <a:endParaRPr b="0" lang="en-US" sz="1000" spc="-1" strike="noStrike">
+                        <a:solidFill>
+                          <a:srgbClr val="000000"/>
+                        </a:solidFill>
+                        <a:latin typeface="Arial"/>
+                      </a:endParaRPr>
+                    </a:p>
+                  </a:txBody>
+                  <a:tcPr anchor="ctr" marL="91440" marR="91440">
+                    <a:lnL w="13680">
+                      <a:solidFill>
+                        <a:srgbClr val="ffffff"/>
+                      </a:solidFill>
+                      <a:prstDash val="solid"/>
+                    </a:lnL>
+                    <a:lnR w="13680">
+                      <a:solidFill>
+                        <a:srgbClr val="ffffff"/>
+                      </a:solidFill>
+                      <a:prstDash val="solid"/>
+                    </a:lnR>
+                    <a:lnT w="13680">
+                      <a:solidFill>
+                        <a:srgbClr val="ffffff"/>
+                      </a:solidFill>
+                      <a:prstDash val="solid"/>
+                    </a:lnT>
+                    <a:lnB w="13680">
+                      <a:solidFill>
+                        <a:srgbClr val="ffffff"/>
+                      </a:solidFill>
+                      <a:prstDash val="solid"/>
+                    </a:lnB>
+                    <a:solidFill>
+                      <a:srgbClr val="93c47d"/>
+                    </a:solidFill>
+                  </a:tcPr>
+                </a:tc>
+              </a:tr>
+              <a:tr h="415440">
+                <a:tc>
+                  <a:txBody>
+                    <a:bodyPr anchor="t">
+                      <a:noAutofit/>
+                    </a:bodyPr>
+                    <a:p>
+                      <a:pPr>
+                        <a:lnSpc>
+                          <a:spcPct val="100000"/>
+                        </a:lnSpc>
+                      </a:pPr>
+                      <a:r>
+                        <a:rPr b="0" lang="en-US" sz="1000" spc="-1" strike="noStrike">
+                          <a:solidFill>
+                            <a:srgbClr val="000000"/>
+                          </a:solidFill>
+                          <a:latin typeface="Arial"/>
+                        </a:rPr>
+                        <a:t>SCT 2</a:t>
+                      </a:r>
+                      <a:endParaRPr b="0" lang="en-US" sz="1000" spc="-1" strike="noStrike">
+                        <a:solidFill>
+                          <a:srgbClr val="000000"/>
+                        </a:solidFill>
+                        <a:latin typeface="Arial"/>
+                      </a:endParaRPr>
+                    </a:p>
+                  </a:txBody>
+                  <a:tcPr anchor="t" marL="91440" marR="91440">
+                    <a:lnL w="13680">
+                      <a:solidFill>
+                        <a:srgbClr val="ffffff"/>
+                      </a:solidFill>
+                      <a:prstDash val="solid"/>
+                    </a:lnL>
+                    <a:lnR w="13680">
+                      <a:solidFill>
+                        <a:srgbClr val="ffffff"/>
+                      </a:solidFill>
+                      <a:prstDash val="solid"/>
+                    </a:lnR>
+                    <a:lnT w="13680">
+                      <a:solidFill>
+                        <a:srgbClr val="ffffff"/>
+                      </a:solidFill>
+                      <a:prstDash val="solid"/>
+                    </a:lnT>
+                    <a:lnB w="13680">
+                      <a:solidFill>
+                        <a:srgbClr val="ffffff"/>
+                      </a:solidFill>
+                      <a:prstDash val="solid"/>
+                    </a:lnB>
+                    <a:solidFill>
+                      <a:srgbClr val="e7e7e7"/>
+                    </a:solidFill>
+                  </a:tcPr>
+                </a:tc>
+                <a:tc>
+                  <a:txBody>
+                    <a:bodyPr anchor="ctr">
+                      <a:noAutofit/>
+                    </a:bodyPr>
+                    <a:p>
+                      <a:pPr algn="ctr">
+                        <a:lnSpc>
+                          <a:spcPct val="100000"/>
+                        </a:lnSpc>
+                      </a:pPr>
+                      <a:r>
+                        <a:rPr b="0" lang="en-US" sz="1000" spc="-1" strike="noStrike">
+                          <a:solidFill>
+                            <a:srgbClr val="000000"/>
+                          </a:solidFill>
+                          <a:latin typeface="Arial"/>
+                        </a:rPr>
+                        <a:t>10/31</a:t>
+                      </a:r>
+                      <a:endParaRPr b="0" lang="en-US" sz="1000" spc="-1" strike="noStrike">
+                        <a:solidFill>
+                          <a:srgbClr val="000000"/>
+                        </a:solidFill>
+                        <a:latin typeface="Arial"/>
+                      </a:endParaRPr>
+                    </a:p>
+                  </a:txBody>
+                  <a:tcPr anchor="ctr" marL="91440" marR="91440">
+                    <a:lnL w="13680">
+                      <a:solidFill>
+                        <a:srgbClr val="ffffff"/>
+                      </a:solidFill>
+                      <a:prstDash val="solid"/>
+                    </a:lnL>
+                    <a:lnR w="13680">
+                      <a:solidFill>
+                        <a:srgbClr val="ffffff"/>
+                      </a:solidFill>
+                      <a:prstDash val="solid"/>
+                    </a:lnR>
+                    <a:lnT w="13680">
+                      <a:solidFill>
+                        <a:srgbClr val="ffffff"/>
+                      </a:solidFill>
+                      <a:prstDash val="solid"/>
+                    </a:lnT>
+                    <a:lnB w="13680">
+                      <a:solidFill>
+                        <a:srgbClr val="ffffff"/>
+                      </a:solidFill>
+                      <a:prstDash val="solid"/>
+                    </a:lnB>
+                    <a:solidFill>
+                      <a:srgbClr val="93c47d"/>
+                    </a:solidFill>
+                  </a:tcPr>
+                </a:tc>
+                <a:tc>
+                  <a:txBody>
+                    <a:bodyPr anchor="ctr">
+                      <a:noAutofit/>
+                    </a:bodyPr>
+                    <a:p>
+                      <a:pPr algn="ctr">
+                        <a:lnSpc>
+                          <a:spcPct val="100000"/>
+                        </a:lnSpc>
+                      </a:pPr>
+                      <a:r>
+                        <a:rPr b="0" lang="en-US" sz="1000" spc="-1" strike="noStrike">
+                          <a:solidFill>
+                            <a:srgbClr val="000000"/>
+                          </a:solidFill>
+                          <a:latin typeface="Arial"/>
+                        </a:rPr>
+                        <a:t>N/A</a:t>
+                      </a:r>
+                      <a:endParaRPr b="0" lang="en-US" sz="1000" spc="-1" strike="noStrike">
+                        <a:solidFill>
+                          <a:srgbClr val="000000"/>
+                        </a:solidFill>
+                        <a:latin typeface="Arial"/>
+                      </a:endParaRPr>
+                    </a:p>
+                  </a:txBody>
+                  <a:tcPr anchor="ctr" marL="91440" marR="91440">
+                    <a:lnL w="13680">
+                      <a:solidFill>
+                        <a:srgbClr val="ffffff"/>
+                      </a:solidFill>
+                      <a:prstDash val="solid"/>
+                    </a:lnL>
+                    <a:lnR w="13680">
+                      <a:solidFill>
+                        <a:srgbClr val="ffffff"/>
+                      </a:solidFill>
+                      <a:prstDash val="solid"/>
+                    </a:lnR>
+                    <a:lnT w="13680">
+                      <a:solidFill>
+                        <a:srgbClr val="ffffff"/>
+                      </a:solidFill>
+                      <a:prstDash val="solid"/>
+                    </a:lnT>
+                    <a:lnB w="13680">
+                      <a:solidFill>
+                        <a:srgbClr val="ffffff"/>
+                      </a:solidFill>
+                      <a:prstDash val="solid"/>
+                    </a:lnB>
+                    <a:solidFill>
+                      <a:srgbClr val="93c47d"/>
+                    </a:solidFill>
+                  </a:tcPr>
+                </a:tc>
+                <a:tc>
+                  <a:txBody>
+                    <a:bodyPr anchor="ctr">
+                      <a:noAutofit/>
+                    </a:bodyPr>
+                    <a:p>
+                      <a:pPr algn="ctr">
+                        <a:lnSpc>
+                          <a:spcPct val="100000"/>
+                        </a:lnSpc>
+                      </a:pPr>
                       <a:r>
                         <a:rPr b="0" lang="en-US" sz="1000" spc="-1" strike="noStrike">
                           <a:solidFill>
@@ -3900,228 +3621,6 @@
                           <a:srgbClr val="000000"/>
                         </a:solidFill>
                         <a:latin typeface="Arial"/>
-                        <a:ea typeface="Arial"/>
-                      </a:endParaRPr>
-                    </a:p>
-                  </a:txBody>
-                  <a:tcPr anchor="ctr" marL="91440" marR="91440">
-                    <a:lnL w="13680">
-                      <a:solidFill>
-                        <a:srgbClr val="ffffff"/>
-                      </a:solidFill>
-                      <a:prstDash val="solid"/>
-                    </a:lnL>
-                    <a:lnR w="13680">
-                      <a:solidFill>
-                        <a:srgbClr val="ffffff"/>
-                      </a:solidFill>
-                      <a:prstDash val="solid"/>
-                    </a:lnR>
-                    <a:lnT w="13680">
-                      <a:solidFill>
-                        <a:srgbClr val="ffffff"/>
-                      </a:solidFill>
-                      <a:prstDash val="solid"/>
-                    </a:lnT>
-                    <a:lnB w="13680">
-                      <a:solidFill>
-                        <a:srgbClr val="ffffff"/>
-                      </a:solidFill>
-                      <a:prstDash val="solid"/>
-                    </a:lnB>
-                    <a:solidFill>
-                      <a:srgbClr val="93c47d"/>
-                    </a:solidFill>
-                  </a:tcPr>
-                </a:tc>
-              </a:tr>
-              <a:tr h="415440">
-                <a:tc>
-                  <a:txBody>
-                    <a:bodyPr anchor="t">
-                      <a:noAutofit/>
-                    </a:bodyPr>
-                    <a:p>
-                      <a:r>
-                        <a:rPr b="0" lang="en-US" sz="1000" spc="-1" strike="noStrike">
-                          <a:solidFill>
-                            <a:srgbClr val="000000"/>
-                          </a:solidFill>
-                          <a:latin typeface="Arial"/>
-                        </a:rPr>
-                        <a:t>SCT 2</a:t>
-                      </a:r>
-                      <a:endParaRPr b="0" lang="en-US" sz="1000" spc="-1" strike="noStrike">
-                        <a:solidFill>
-                          <a:srgbClr val="000000"/>
-                        </a:solidFill>
-                        <a:latin typeface="Arial"/>
-                        <a:ea typeface="Arial"/>
-                      </a:endParaRPr>
-                    </a:p>
-                  </a:txBody>
-                  <a:tcPr anchor="t" marL="91440" marR="91440">
-                    <a:lnL w="13680">
-                      <a:solidFill>
-                        <a:srgbClr val="ffffff"/>
-                      </a:solidFill>
-                      <a:prstDash val="solid"/>
-                    </a:lnL>
-                    <a:lnR w="13680">
-                      <a:solidFill>
-                        <a:srgbClr val="ffffff"/>
-                      </a:solidFill>
-                      <a:prstDash val="solid"/>
-                    </a:lnR>
-                    <a:lnT w="13680">
-                      <a:solidFill>
-                        <a:srgbClr val="ffffff"/>
-                      </a:solidFill>
-                      <a:prstDash val="solid"/>
-                    </a:lnT>
-                    <a:lnB w="13680">
-                      <a:solidFill>
-                        <a:srgbClr val="ffffff"/>
-                      </a:solidFill>
-                      <a:prstDash val="solid"/>
-                    </a:lnB>
-                    <a:solidFill>
-                      <a:srgbClr val="e7e7e7"/>
-                    </a:solidFill>
-                  </a:tcPr>
-                </a:tc>
-                <a:tc>
-                  <a:txBody>
-                    <a:bodyPr anchor="ctr">
-                      <a:noAutofit/>
-                    </a:bodyPr>
-                    <a:p>
-                      <a:pPr algn="ctr"/>
-                      <a:r>
-                        <a:rPr b="0" lang="en-US" sz="1000" spc="-1" strike="noStrike">
-                          <a:solidFill>
-                            <a:srgbClr val="000000"/>
-                          </a:solidFill>
-                          <a:latin typeface="Arial"/>
-                        </a:rPr>
-                        <a:t>10/31</a:t>
-                      </a:r>
-                      <a:endParaRPr b="0" lang="en-US" sz="1000" spc="-1" strike="noStrike">
-                        <a:solidFill>
-                          <a:srgbClr val="000000"/>
-                        </a:solidFill>
-                        <a:latin typeface="Arial"/>
-                        <a:ea typeface="Arial"/>
-                      </a:endParaRPr>
-                    </a:p>
-                  </a:txBody>
-                  <a:tcPr anchor="ctr" marL="91440" marR="91440">
-                    <a:lnL w="13680">
-                      <a:solidFill>
-                        <a:srgbClr val="ffffff"/>
-                      </a:solidFill>
-                      <a:prstDash val="solid"/>
-                    </a:lnL>
-                    <a:lnR w="13680">
-                      <a:solidFill>
-                        <a:srgbClr val="ffffff"/>
-                      </a:solidFill>
-                      <a:prstDash val="solid"/>
-                    </a:lnR>
-                    <a:lnT w="13680">
-                      <a:solidFill>
-                        <a:srgbClr val="ffffff"/>
-                      </a:solidFill>
-                      <a:prstDash val="solid"/>
-                    </a:lnT>
-                    <a:lnB w="13680">
-                      <a:solidFill>
-                        <a:srgbClr val="ffffff"/>
-                      </a:solidFill>
-                      <a:prstDash val="solid"/>
-                    </a:lnB>
-                    <a:solidFill>
-                      <a:srgbClr val="93c47d"/>
-                    </a:solidFill>
-                  </a:tcPr>
-                </a:tc>
-                <a:tc>
-                  <a:txBody>
-                    <a:bodyPr anchor="ctr">
-                      <a:noAutofit/>
-                    </a:bodyPr>
-                    <a:p>
-                      <a:pPr algn="ctr"/>
-                      <a:r>
-                        <a:rPr b="0" lang="en-US" sz="1000" spc="-1" strike="noStrike">
-                          <a:solidFill>
-                            <a:srgbClr val="000000"/>
-                          </a:solidFill>
-                          <a:latin typeface="Arial"/>
-                        </a:rPr>
-                        <a:t>N/A</a:t>
-                      </a:r>
-                      <a:endParaRPr b="0" lang="en-US" sz="1000" spc="-1" strike="noStrike">
-                        <a:solidFill>
-                          <a:srgbClr val="000000"/>
-                        </a:solidFill>
-                        <a:latin typeface="Arial"/>
-                        <a:ea typeface="Arial"/>
-                      </a:endParaRPr>
-                    </a:p>
-                  </a:txBody>
-                  <a:tcPr anchor="ctr" marL="91440" marR="91440">
-                    <a:lnL w="13680">
-                      <a:solidFill>
-                        <a:srgbClr val="ffffff"/>
-                      </a:solidFill>
-                      <a:prstDash val="solid"/>
-                    </a:lnL>
-                    <a:lnR w="13680">
-                      <a:solidFill>
-                        <a:srgbClr val="ffffff"/>
-                      </a:solidFill>
-                      <a:prstDash val="solid"/>
-                    </a:lnR>
-                    <a:lnT w="13680">
-                      <a:solidFill>
-                        <a:srgbClr val="ffffff"/>
-                      </a:solidFill>
-                      <a:prstDash val="solid"/>
-                    </a:lnT>
-                    <a:lnB w="13680">
-                      <a:solidFill>
-                        <a:srgbClr val="ffffff"/>
-                      </a:solidFill>
-                      <a:prstDash val="solid"/>
-                    </a:lnB>
-                    <a:solidFill>
-                      <a:srgbClr val="93c47d"/>
-                    </a:solidFill>
-                  </a:tcPr>
-                </a:tc>
-                <a:tc>
-                  <a:txBody>
-                    <a:bodyPr anchor="ctr">
-                      <a:noAutofit/>
-                    </a:bodyPr>
-                    <a:p>
-                      <a:pPr algn="ctr"/>
-                      <a:r>
-                        <a:rPr b="0" lang="en-US" sz="1000" spc="-1" strike="noStrike">
-                          <a:solidFill>
-                            <a:srgbClr val="000000"/>
-                          </a:solidFill>
-                          <a:latin typeface="Arial"/>
-                        </a:rPr>
-                        <a:t>27hrs</a:t>
-                      </a:r>
-                      <a:endParaRPr b="0" lang="en-US" sz="1000" spc="-1" strike="noStrike">
-                        <a:solidFill>
-                          <a:srgbClr val="000000"/>
-                        </a:solidFill>
-                        <a:latin typeface="Arial"/>
-                        <a:ea typeface="Arial"/>
                       </a:endParaRPr>
                     </a:p>
                   </a:txBody>
@@ -4162,14 +3661,14 @@
       </p:graphicFrame>
       <p:sp>
         <p:nvSpPr>
-          <p:cNvPr id="28" name="Google Shape;51;p4"/>
+          <p:cNvPr id="26" name="Google Shape;51;p4"/>
           <p:cNvSpPr/>
           <p:nvPr/>
         </p:nvSpPr>
         <p:spPr>
           <a:xfrm>
             <a:off x="0" y="11880"/>
-            <a:ext cx="2654640" cy="573480"/>
+            <a:ext cx="2654280" cy="573120"/>
           </a:xfrm>
           <a:prstGeom prst="rect">
             <a:avLst/>
@@ -4186,7 +3685,7 @@
           <a:fontRef idx="minor"/>
         </p:style>
         <p:txBody>
-          <a:bodyPr tIns="91440" bIns="91440" anchor="t">
+          <a:bodyPr lIns="90000" rIns="90000" tIns="91440" bIns="91440" anchor="t">
             <a:noAutofit/>
           </a:bodyPr>
           <a:p>

</xml_diff>